<commit_message>
docs(pptx): add 'Progress to date' slide + speaker notes on every slide
10 slides now (was 9): new progress/status slide after the title. Every slide
carries presenter notes (verbal talking points) via the notes pane.

Co-Authored-By: Claude Opus 4.8 (1M context) <noreply@anthropic.com>
</commit_message>
<xml_diff>
--- a/docs/presentations/SLSTR_EarthCARE_validation_Dec2025.pptx
+++ b/docs/presentations/SLSTR_EarthCARE_validation_Dec2025.pptx
@@ -6,14 +6,15 @@
   </p:sldMasterIdLst>
   <p:sldIdLst>
     <p:sldId id="256" r:id="rId7"/>
-    <p:sldId id="257" r:id="rId8"/>
-    <p:sldId id="258" r:id="rId9"/>
-    <p:sldId id="259" r:id="rId10"/>
-    <p:sldId id="260" r:id="rId11"/>
-    <p:sldId id="261" r:id="rId12"/>
-    <p:sldId id="262" r:id="rId13"/>
-    <p:sldId id="263" r:id="rId14"/>
-    <p:sldId id="264" r:id="rId15"/>
+    <p:sldId id="257" r:id="rId9"/>
+    <p:sldId id="258" r:id="rId10"/>
+    <p:sldId id="259" r:id="rId11"/>
+    <p:sldId id="260" r:id="rId12"/>
+    <p:sldId id="261" r:id="rId13"/>
+    <p:sldId id="262" r:id="rId14"/>
+    <p:sldId id="263" r:id="rId15"/>
+    <p:sldId id="264" r:id="rId16"/>
+    <p:sldId id="265" r:id="rId17"/>
   </p:sldIdLst>
   <p:sldSz cx="12191695" cy="6858000" type="screen4x3"/>
   <p:notesSz cx="6858000" cy="9144000"/>
@@ -113,6 +114,1056 @@
     </a:lvl9pPr>
   </p:defaultTextStyle>
 </p:presentation>
+</file>
+
+<file path=ppt/notesMasters/notesMaster1.xml><?xml version="1.0" encoding="utf-8"?>
+<p:notesMaster xmlns:a="http://schemas.openxmlformats.org/drawingml/2006/main" xmlns:p="http://schemas.openxmlformats.org/presentationml/2006/main" xmlns:r="http://schemas.openxmlformats.org/officeDocument/2006/relationships">
+  <p:cSld>
+    <p:bg>
+      <p:bgRef idx="1001">
+        <a:schemeClr val="bg1"/>
+      </p:bgRef>
+    </p:bg>
+    <p:spTree>
+      <p:nvGrpSpPr>
+        <p:cNvPr id="1" name=""/>
+        <p:cNvGrpSpPr/>
+        <p:nvPr/>
+      </p:nvGrpSpPr>
+      <p:grpSpPr>
+        <a:xfrm>
+          <a:off x="0" y="0"/>
+          <a:ext cx="0" cy="0"/>
+          <a:chOff x="0" y="0"/>
+          <a:chExt cx="0" cy="0"/>
+        </a:xfrm>
+      </p:grpSpPr>
+      <p:sp>
+        <p:nvSpPr>
+          <p:cNvPr id="2" name="Header Placeholder 1"/>
+          <p:cNvSpPr>
+            <a:spLocks noGrp="1"/>
+          </p:cNvSpPr>
+          <p:nvPr>
+            <p:ph type="hdr" sz="quarter"/>
+          </p:nvPr>
+        </p:nvSpPr>
+        <p:spPr>
+          <a:xfrm>
+            <a:off x="0" y="0"/>
+            <a:ext cx="2971800" cy="457200"/>
+          </a:xfrm>
+          <a:prstGeom prst="rect">
+            <a:avLst/>
+          </a:prstGeom>
+        </p:spPr>
+        <p:txBody>
+          <a:bodyPr vert="horz" lIns="91440" tIns="45720" rIns="91440" bIns="45720" rtlCol="0"/>
+          <a:lstStyle>
+            <a:lvl1pPr algn="l">
+              <a:defRPr sz="1200"/>
+            </a:lvl1pPr>
+          </a:lstStyle>
+          <a:p>
+            <a:endParaRPr lang="en-US"/>
+          </a:p>
+        </p:txBody>
+      </p:sp>
+      <p:sp>
+        <p:nvSpPr>
+          <p:cNvPr id="3" name="Date Placeholder 2"/>
+          <p:cNvSpPr>
+            <a:spLocks noGrp="1"/>
+          </p:cNvSpPr>
+          <p:nvPr>
+            <p:ph type="dt" idx="1"/>
+          </p:nvPr>
+        </p:nvSpPr>
+        <p:spPr>
+          <a:xfrm>
+            <a:off x="3884613" y="0"/>
+            <a:ext cx="2971800" cy="457200"/>
+          </a:xfrm>
+          <a:prstGeom prst="rect">
+            <a:avLst/>
+          </a:prstGeom>
+        </p:spPr>
+        <p:txBody>
+          <a:bodyPr vert="horz" lIns="91440" tIns="45720" rIns="91440" bIns="45720" rtlCol="0"/>
+          <a:lstStyle>
+            <a:lvl1pPr algn="r">
+              <a:defRPr sz="1200"/>
+            </a:lvl1pPr>
+          </a:lstStyle>
+          <a:p>
+            <a:fld id="{0F89C1C7-3DCD-1040-A9CF-14679D8B5DDD}" type="datetimeFigureOut">
+              <a:rPr lang="en-US" smtClean="0"/>
+              <a:t>10/17/16</a:t>
+            </a:fld>
+            <a:endParaRPr lang="en-US"/>
+          </a:p>
+        </p:txBody>
+      </p:sp>
+      <p:sp>
+        <p:nvSpPr>
+          <p:cNvPr id="4" name="Slide Image Placeholder 3"/>
+          <p:cNvSpPr>
+            <a:spLocks noGrp="1" noRot="1" noChangeAspect="1"/>
+          </p:cNvSpPr>
+          <p:nvPr>
+            <p:ph type="sldImg" idx="2"/>
+          </p:nvPr>
+        </p:nvSpPr>
+        <p:spPr>
+          <a:xfrm>
+            <a:off x="1143000" y="685800"/>
+            <a:ext cx="4572000" cy="3429000"/>
+          </a:xfrm>
+          <a:prstGeom prst="rect">
+            <a:avLst/>
+          </a:prstGeom>
+          <a:noFill/>
+          <a:ln w="12700">
+            <a:solidFill>
+              <a:prstClr val="black"/>
+            </a:solidFill>
+          </a:ln>
+        </p:spPr>
+        <p:txBody>
+          <a:bodyPr vert="horz" lIns="91440" tIns="45720" rIns="91440" bIns="45720" rtlCol="0" anchor="ctr"/>
+          <a:lstStyle/>
+          <a:p>
+            <a:endParaRPr lang="en-US"/>
+          </a:p>
+        </p:txBody>
+      </p:sp>
+      <p:sp>
+        <p:nvSpPr>
+          <p:cNvPr id="5" name="Notes Placeholder 4"/>
+          <p:cNvSpPr>
+            <a:spLocks noGrp="1"/>
+          </p:cNvSpPr>
+          <p:nvPr>
+            <p:ph type="body" sz="quarter" idx="3"/>
+          </p:nvPr>
+        </p:nvSpPr>
+        <p:spPr>
+          <a:xfrm>
+            <a:off x="685800" y="4343400"/>
+            <a:ext cx="5486400" cy="4114800"/>
+          </a:xfrm>
+          <a:prstGeom prst="rect">
+            <a:avLst/>
+          </a:prstGeom>
+        </p:spPr>
+        <p:txBody>
+          <a:bodyPr vert="horz" lIns="91440" tIns="45720" rIns="91440" bIns="45720" rtlCol="0"/>
+          <a:lstStyle/>
+          <a:p>
+            <a:pPr lvl="0"/>
+            <a:r>
+              <a:rPr lang="en-US" smtClean="0"/>
+              <a:t>Click to edit Master text styles</a:t>
+            </a:r>
+          </a:p>
+          <a:p>
+            <a:pPr lvl="1"/>
+            <a:r>
+              <a:rPr lang="en-US" smtClean="0"/>
+              <a:t>Second level</a:t>
+            </a:r>
+          </a:p>
+          <a:p>
+            <a:pPr lvl="2"/>
+            <a:r>
+              <a:rPr lang="en-US" smtClean="0"/>
+              <a:t>Third level</a:t>
+            </a:r>
+          </a:p>
+          <a:p>
+            <a:pPr lvl="3"/>
+            <a:r>
+              <a:rPr lang="en-US" smtClean="0"/>
+              <a:t>Fourth level</a:t>
+            </a:r>
+          </a:p>
+          <a:p>
+            <a:pPr lvl="4"/>
+            <a:r>
+              <a:rPr lang="en-US" smtClean="0"/>
+              <a:t>Fifth level</a:t>
+            </a:r>
+            <a:endParaRPr lang="en-US"/>
+          </a:p>
+        </p:txBody>
+      </p:sp>
+      <p:sp>
+        <p:nvSpPr>
+          <p:cNvPr id="6" name="Footer Placeholder 5"/>
+          <p:cNvSpPr>
+            <a:spLocks noGrp="1"/>
+          </p:cNvSpPr>
+          <p:nvPr>
+            <p:ph type="ftr" sz="quarter" idx="4"/>
+          </p:nvPr>
+        </p:nvSpPr>
+        <p:spPr>
+          <a:xfrm>
+            <a:off x="0" y="8685213"/>
+            <a:ext cx="2971800" cy="457200"/>
+          </a:xfrm>
+          <a:prstGeom prst="rect">
+            <a:avLst/>
+          </a:prstGeom>
+        </p:spPr>
+        <p:txBody>
+          <a:bodyPr vert="horz" lIns="91440" tIns="45720" rIns="91440" bIns="45720" rtlCol="0" anchor="b"/>
+          <a:lstStyle>
+            <a:lvl1pPr algn="l">
+              <a:defRPr sz="1200"/>
+            </a:lvl1pPr>
+          </a:lstStyle>
+          <a:p>
+            <a:endParaRPr lang="en-US"/>
+          </a:p>
+        </p:txBody>
+      </p:sp>
+      <p:sp>
+        <p:nvSpPr>
+          <p:cNvPr id="7" name="Slide Number Placeholder 6"/>
+          <p:cNvSpPr>
+            <a:spLocks noGrp="1"/>
+          </p:cNvSpPr>
+          <p:nvPr>
+            <p:ph type="sldNum" sz="quarter" idx="5"/>
+          </p:nvPr>
+        </p:nvSpPr>
+        <p:spPr>
+          <a:xfrm>
+            <a:off x="3884613" y="8685213"/>
+            <a:ext cx="2971800" cy="457200"/>
+          </a:xfrm>
+          <a:prstGeom prst="rect">
+            <a:avLst/>
+          </a:prstGeom>
+        </p:spPr>
+        <p:txBody>
+          <a:bodyPr vert="horz" lIns="91440" tIns="45720" rIns="91440" bIns="45720" rtlCol="0" anchor="b"/>
+          <a:lstStyle>
+            <a:lvl1pPr algn="r">
+              <a:defRPr sz="1200"/>
+            </a:lvl1pPr>
+          </a:lstStyle>
+          <a:p>
+            <a:fld id="{BB5E49A5-4136-284D-997B-48E1D791AD67}" type="slidenum">
+              <a:rPr lang="en-US" smtClean="0"/>
+              <a:t>‹#›</a:t>
+            </a:fld>
+            <a:endParaRPr lang="en-US"/>
+          </a:p>
+        </p:txBody>
+      </p:sp>
+    </p:spTree>
+    <p:extLst>
+      <p:ext uri="{BB962C8B-B14F-4D97-AF65-F5344CB8AC3E}">
+        <p14:creationId xmlns:p14="http://schemas.microsoft.com/office/powerpoint/2010/main" val="2623252185"/>
+      </p:ext>
+    </p:extLst>
+  </p:cSld>
+  <p:clrMap bg1="lt1" tx1="dk1" bg2="lt2" tx2="dk2" accent1="accent1" accent2="accent2" accent3="accent3" accent4="accent4" accent5="accent5" accent6="accent6" hlink="hlink" folHlink="folHlink"/>
+  <p:notesStyle>
+    <a:lvl1pPr marL="0" algn="l" defTabSz="457200" rtl="0" eaLnBrk="1" latinLnBrk="0" hangingPunct="1">
+      <a:defRPr sz="1200" kern="1200">
+        <a:solidFill>
+          <a:schemeClr val="tx1"/>
+        </a:solidFill>
+        <a:latin typeface="+mn-lt"/>
+        <a:ea typeface="+mn-ea"/>
+        <a:cs typeface="+mn-cs"/>
+      </a:defRPr>
+    </a:lvl1pPr>
+    <a:lvl2pPr marL="457200" algn="l" defTabSz="457200" rtl="0" eaLnBrk="1" latinLnBrk="0" hangingPunct="1">
+      <a:defRPr sz="1200" kern="1200">
+        <a:solidFill>
+          <a:schemeClr val="tx1"/>
+        </a:solidFill>
+        <a:latin typeface="+mn-lt"/>
+        <a:ea typeface="+mn-ea"/>
+        <a:cs typeface="+mn-cs"/>
+      </a:defRPr>
+    </a:lvl2pPr>
+    <a:lvl3pPr marL="914400" algn="l" defTabSz="457200" rtl="0" eaLnBrk="1" latinLnBrk="0" hangingPunct="1">
+      <a:defRPr sz="1200" kern="1200">
+        <a:solidFill>
+          <a:schemeClr val="tx1"/>
+        </a:solidFill>
+        <a:latin typeface="+mn-lt"/>
+        <a:ea typeface="+mn-ea"/>
+        <a:cs typeface="+mn-cs"/>
+      </a:defRPr>
+    </a:lvl3pPr>
+    <a:lvl4pPr marL="1371600" algn="l" defTabSz="457200" rtl="0" eaLnBrk="1" latinLnBrk="0" hangingPunct="1">
+      <a:defRPr sz="1200" kern="1200">
+        <a:solidFill>
+          <a:schemeClr val="tx1"/>
+        </a:solidFill>
+        <a:latin typeface="+mn-lt"/>
+        <a:ea typeface="+mn-ea"/>
+        <a:cs typeface="+mn-cs"/>
+      </a:defRPr>
+    </a:lvl4pPr>
+    <a:lvl5pPr marL="1828800" algn="l" defTabSz="457200" rtl="0" eaLnBrk="1" latinLnBrk="0" hangingPunct="1">
+      <a:defRPr sz="1200" kern="1200">
+        <a:solidFill>
+          <a:schemeClr val="tx1"/>
+        </a:solidFill>
+        <a:latin typeface="+mn-lt"/>
+        <a:ea typeface="+mn-ea"/>
+        <a:cs typeface="+mn-cs"/>
+      </a:defRPr>
+    </a:lvl5pPr>
+    <a:lvl6pPr marL="2286000" algn="l" defTabSz="457200" rtl="0" eaLnBrk="1" latinLnBrk="0" hangingPunct="1">
+      <a:defRPr sz="1200" kern="1200">
+        <a:solidFill>
+          <a:schemeClr val="tx1"/>
+        </a:solidFill>
+        <a:latin typeface="+mn-lt"/>
+        <a:ea typeface="+mn-ea"/>
+        <a:cs typeface="+mn-cs"/>
+      </a:defRPr>
+    </a:lvl6pPr>
+    <a:lvl7pPr marL="2743200" algn="l" defTabSz="457200" rtl="0" eaLnBrk="1" latinLnBrk="0" hangingPunct="1">
+      <a:defRPr sz="1200" kern="1200">
+        <a:solidFill>
+          <a:schemeClr val="tx1"/>
+        </a:solidFill>
+        <a:latin typeface="+mn-lt"/>
+        <a:ea typeface="+mn-ea"/>
+        <a:cs typeface="+mn-cs"/>
+      </a:defRPr>
+    </a:lvl7pPr>
+    <a:lvl8pPr marL="3200400" algn="l" defTabSz="457200" rtl="0" eaLnBrk="1" latinLnBrk="0" hangingPunct="1">
+      <a:defRPr sz="1200" kern="1200">
+        <a:solidFill>
+          <a:schemeClr val="tx1"/>
+        </a:solidFill>
+        <a:latin typeface="+mn-lt"/>
+        <a:ea typeface="+mn-ea"/>
+        <a:cs typeface="+mn-cs"/>
+      </a:defRPr>
+    </a:lvl8pPr>
+    <a:lvl9pPr marL="3657600" algn="l" defTabSz="457200" rtl="0" eaLnBrk="1" latinLnBrk="0" hangingPunct="1">
+      <a:defRPr sz="1200" kern="1200">
+        <a:solidFill>
+          <a:schemeClr val="tx1"/>
+        </a:solidFill>
+        <a:latin typeface="+mn-lt"/>
+        <a:ea typeface="+mn-ea"/>
+        <a:cs typeface="+mn-cs"/>
+      </a:defRPr>
+    </a:lvl9pPr>
+  </p:notesStyle>
+</p:notesMaster>
+</file>
+
+<file path=ppt/notesSlides/notesSlide1.xml><?xml version="1.0" encoding="utf-8"?>
+<p:notes xmlns:a="http://schemas.openxmlformats.org/drawingml/2006/main" xmlns:p="http://schemas.openxmlformats.org/presentationml/2006/main" xmlns:r="http://schemas.openxmlformats.org/officeDocument/2006/relationships">
+  <p:cSld>
+    <p:spTree>
+      <p:nvGrpSpPr>
+        <p:cNvPr id="1" name=""/>
+        <p:cNvGrpSpPr/>
+        <p:nvPr/>
+      </p:nvGrpSpPr>
+      <p:grpSpPr>
+        <a:xfrm>
+          <a:off x="0" y="0"/>
+          <a:ext cx="0" cy="0"/>
+          <a:chOff x="0" y="0"/>
+          <a:chExt cx="0" cy="0"/>
+        </a:xfrm>
+      </p:grpSpPr>
+      <p:sp>
+        <p:nvSpPr>
+          <p:cNvPr id="2" name="Slide Image Placeholder 1"/>
+          <p:cNvSpPr>
+            <a:spLocks noGrp="1"/>
+          </p:cNvSpPr>
+          <p:nvPr>
+            <p:ph type="sldImg" idx="2"/>
+          </p:nvPr>
+        </p:nvSpPr>
+        <p:spPr/>
+      </p:sp>
+      <p:sp>
+        <p:nvSpPr>
+          <p:cNvPr id="3" name="Notes Placeholder 2"/>
+          <p:cNvSpPr>
+            <a:spLocks noGrp="1"/>
+          </p:cNvSpPr>
+          <p:nvPr>
+            <p:ph type="body" idx="3" sz="quarter"/>
+          </p:nvPr>
+        </p:nvSpPr>
+        <p:spPr/>
+        <p:txBody>
+          <a:bodyPr/>
+          <a:lstStyle/>
+          <a:p>
+            <a:r>
+              <a:t>Framing. We've extended our SEVIRI x EarthCARE validation framework to ORAC retrievals on Sentinel-3A SLSTR, using EarthCARE as the reference, for December 2025. The story I'll build to is two independent limitations of the polar-daytime solar retrieval - a bright-surface optical-depth saturation, and an intrinsic liquid phase bias - while the thermal cloud-top height and the effective radius come out well. The sample is about 0.6 million matched pixels.</a:t>
+            </a:r>
+          </a:p>
+        </p:txBody>
+      </p:sp>
+      <p:sp>
+        <p:nvSpPr>
+          <p:cNvPr id="4" name="Slide Number Placeholder 3"/>
+          <p:cNvSpPr>
+            <a:spLocks noGrp="1"/>
+          </p:cNvSpPr>
+          <p:nvPr>
+            <p:ph type="sldNum" idx="5" sz="quarter"/>
+          </p:nvPr>
+        </p:nvSpPr>
+        <p:spPr/>
+      </p:sp>
+    </p:spTree>
+  </p:cSld>
+  <p:clrMapOvr>
+    <a:masterClrMapping/>
+  </p:clrMapOvr>
+</p:notes>
+</file>
+
+<file path=ppt/notesSlides/notesSlide10.xml><?xml version="1.0" encoding="utf-8"?>
+<p:notes xmlns:a="http://schemas.openxmlformats.org/drawingml/2006/main" xmlns:p="http://schemas.openxmlformats.org/presentationml/2006/main" xmlns:r="http://schemas.openxmlformats.org/officeDocument/2006/relationships">
+  <p:cSld>
+    <p:spTree>
+      <p:nvGrpSpPr>
+        <p:cNvPr id="1" name=""/>
+        <p:cNvGrpSpPr/>
+        <p:nvPr/>
+      </p:nvGrpSpPr>
+      <p:grpSpPr>
+        <a:xfrm>
+          <a:off x="0" y="0"/>
+          <a:ext cx="0" cy="0"/>
+          <a:chOff x="0" y="0"/>
+          <a:chExt cx="0" cy="0"/>
+        </a:xfrm>
+      </p:grpSpPr>
+      <p:sp>
+        <p:nvSpPr>
+          <p:cNvPr id="2" name="Slide Image Placeholder 1"/>
+          <p:cNvSpPr>
+            <a:spLocks noGrp="1"/>
+          </p:cNvSpPr>
+          <p:nvPr>
+            <p:ph type="sldImg" idx="2"/>
+          </p:nvPr>
+        </p:nvSpPr>
+        <p:spPr/>
+      </p:sp>
+      <p:sp>
+        <p:nvSpPr>
+          <p:cNvPr id="3" name="Notes Placeholder 2"/>
+          <p:cNvSpPr>
+            <a:spLocks noGrp="1"/>
+          </p:cNvSpPr>
+          <p:nvPr>
+            <p:ph type="body" idx="3" sz="quarter"/>
+          </p:nvPr>
+        </p:nvSpPr>
+        <p:spPr/>
+        <p:txBody>
+          <a:bodyPr/>
+          <a:lstStyle/>
+          <a:p>
+            <a:r>
+              <a:t>To close. Everything is validated and defensible as an Antarctic-summer daytime study, with cloud-top height also bi-hemispheric. The unifying message is two independent limitations: a surface-driven optical-depth saturation that also hits the water path, and an intrinsic liquid phase bias. The reliable products are cloud-top height and effective radius. The next steps all require new processing rather than more analysis - a boreal-summer month to test the Arctic, Sentinel-3B for a second platform, and other seasons. Happy to take questions.</a:t>
+            </a:r>
+          </a:p>
+        </p:txBody>
+      </p:sp>
+      <p:sp>
+        <p:nvSpPr>
+          <p:cNvPr id="4" name="Slide Number Placeholder 3"/>
+          <p:cNvSpPr>
+            <a:spLocks noGrp="1"/>
+          </p:cNvSpPr>
+          <p:nvPr>
+            <p:ph type="sldNum" idx="5" sz="quarter"/>
+          </p:nvPr>
+        </p:nvSpPr>
+        <p:spPr/>
+      </p:sp>
+    </p:spTree>
+  </p:cSld>
+  <p:clrMapOvr>
+    <a:masterClrMapping/>
+  </p:clrMapOvr>
+</p:notes>
+</file>
+
+<file path=ppt/notesSlides/notesSlide2.xml><?xml version="1.0" encoding="utf-8"?>
+<p:notes xmlns:a="http://schemas.openxmlformats.org/drawingml/2006/main" xmlns:p="http://schemas.openxmlformats.org/presentationml/2006/main" xmlns:r="http://schemas.openxmlformats.org/officeDocument/2006/relationships">
+  <p:cSld>
+    <p:spTree>
+      <p:nvGrpSpPr>
+        <p:cNvPr id="1" name=""/>
+        <p:cNvGrpSpPr/>
+        <p:nvPr/>
+      </p:nvGrpSpPr>
+      <p:grpSpPr>
+        <a:xfrm>
+          <a:off x="0" y="0"/>
+          <a:ext cx="0" cy="0"/>
+          <a:chOff x="0" y="0"/>
+          <a:chExt cx="0" cy="0"/>
+        </a:xfrm>
+      </p:grpSpPr>
+      <p:sp>
+        <p:nvSpPr>
+          <p:cNvPr id="2" name="Slide Image Placeholder 1"/>
+          <p:cNvSpPr>
+            <a:spLocks noGrp="1"/>
+          </p:cNvSpPr>
+          <p:nvPr>
+            <p:ph type="sldImg" idx="2"/>
+          </p:nvPr>
+        </p:nvSpPr>
+        <p:spPr/>
+      </p:sp>
+      <p:sp>
+        <p:nvSpPr>
+          <p:cNvPr id="3" name="Notes Placeholder 2"/>
+          <p:cNvSpPr>
+            <a:spLocks noGrp="1"/>
+          </p:cNvSpPr>
+          <p:nvPr>
+            <p:ph type="body" idx="3" sz="quarter"/>
+          </p:nvPr>
+        </p:nvSpPr>
+        <p:spPr/>
+        <p:txBody>
+          <a:bodyPr/>
+          <a:lstStyle/>
+          <a:p>
+            <a:r>
+              <a:t>Quick status before the detail. The collocation pipeline is built and characterised. Every continuous variable is validated against EarthCARE. We've done the root-cause analysis behind the biases. And - new since the last meeting - we've closed the two-way phase validation using A-TC, which lets us report ice-detection skill for the first time. All of it is written up as reports plus this deck, and it's reproducible. What remains needs new data processing - a summer Arctic month, Sentinel-3B, other seasons - not more analysis of what we have.</a:t>
+            </a:r>
+          </a:p>
+        </p:txBody>
+      </p:sp>
+      <p:sp>
+        <p:nvSpPr>
+          <p:cNvPr id="4" name="Slide Number Placeholder 3"/>
+          <p:cNvSpPr>
+            <a:spLocks noGrp="1"/>
+          </p:cNvSpPr>
+          <p:nvPr>
+            <p:ph type="sldNum" idx="5" sz="quarter"/>
+          </p:nvPr>
+        </p:nvSpPr>
+        <p:spPr/>
+      </p:sp>
+    </p:spTree>
+  </p:cSld>
+  <p:clrMapOvr>
+    <a:masterClrMapping/>
+  </p:clrMapOvr>
+</p:notes>
+</file>
+
+<file path=ppt/notesSlides/notesSlide3.xml><?xml version="1.0" encoding="utf-8"?>
+<p:notes xmlns:a="http://schemas.openxmlformats.org/drawingml/2006/main" xmlns:p="http://schemas.openxmlformats.org/presentationml/2006/main" xmlns:r="http://schemas.openxmlformats.org/officeDocument/2006/relationships">
+  <p:cSld>
+    <p:spTree>
+      <p:nvGrpSpPr>
+        <p:cNvPr id="1" name=""/>
+        <p:cNvGrpSpPr/>
+        <p:nvPr/>
+      </p:nvGrpSpPr>
+      <p:grpSpPr>
+        <a:xfrm>
+          <a:off x="0" y="0"/>
+          <a:ext cx="0" cy="0"/>
+          <a:chOff x="0" y="0"/>
+          <a:chExt cx="0" cy="0"/>
+        </a:xfrm>
+      </p:grpSpPr>
+      <p:sp>
+        <p:nvSpPr>
+          <p:cNvPr id="2" name="Slide Image Placeholder 1"/>
+          <p:cNvSpPr>
+            <a:spLocks noGrp="1"/>
+          </p:cNvSpPr>
+          <p:nvPr>
+            <p:ph type="sldImg" idx="2"/>
+          </p:nvPr>
+        </p:nvSpPr>
+        <p:spPr/>
+      </p:sp>
+      <p:sp>
+        <p:nvSpPr>
+          <p:cNvPr id="3" name="Notes Placeholder 2"/>
+          <p:cNvSpPr>
+            <a:spLocks noGrp="1"/>
+          </p:cNvSpPr>
+          <p:nvPr>
+            <p:ph type="body" idx="3" sz="quarter"/>
+          </p:nvPr>
+        </p:nvSpPr>
+        <p:spPr/>
+        <p:txBody>
+          <a:bodyPr/>
+          <a:lstStyle/>
+          <a:p>
+            <a:r>
+              <a:t>Why this is a polar study: two sun-synchronous orbiters only coincide near the poles, so every collocation is polar - that's orbital mechanics, not a choice. We match within an hour and 3 km, and both footprints are about a kilometre. The key consequence: the solar retrievals need daylight, and in December that's Antarctic polar day, so the entire optical-depth, effective-radius, water-path and phase sample is Southern Hemisphere. Only the thermal cloud-top height, which works at night, also sees the Arctic. The map shows where the crossings concentrate - a dense polar band, sparse elsewhere.</a:t>
+            </a:r>
+          </a:p>
+        </p:txBody>
+      </p:sp>
+      <p:sp>
+        <p:nvSpPr>
+          <p:cNvPr id="4" name="Slide Number Placeholder 3"/>
+          <p:cNvSpPr>
+            <a:spLocks noGrp="1"/>
+          </p:cNvSpPr>
+          <p:nvPr>
+            <p:ph type="sldNum" idx="5" sz="quarter"/>
+          </p:nvPr>
+        </p:nvSpPr>
+        <p:spPr/>
+      </p:sp>
+    </p:spTree>
+  </p:cSld>
+  <p:clrMapOvr>
+    <a:masterClrMapping/>
+  </p:clrMapOvr>
+</p:notes>
+</file>
+
+<file path=ppt/notesSlides/notesSlide4.xml><?xml version="1.0" encoding="utf-8"?>
+<p:notes xmlns:a="http://schemas.openxmlformats.org/drawingml/2006/main" xmlns:p="http://schemas.openxmlformats.org/presentationml/2006/main" xmlns:r="http://schemas.openxmlformats.org/officeDocument/2006/relationships">
+  <p:cSld>
+    <p:spTree>
+      <p:nvGrpSpPr>
+        <p:cNvPr id="1" name=""/>
+        <p:cNvGrpSpPr/>
+        <p:nvPr/>
+      </p:nvGrpSpPr>
+      <p:grpSpPr>
+        <a:xfrm>
+          <a:off x="0" y="0"/>
+          <a:ext cx="0" cy="0"/>
+          <a:chOff x="0" y="0"/>
+          <a:chExt cx="0" cy="0"/>
+        </a:xfrm>
+      </p:grpSpPr>
+      <p:sp>
+        <p:nvSpPr>
+          <p:cNvPr id="2" name="Slide Image Placeholder 1"/>
+          <p:cNvSpPr>
+            <a:spLocks noGrp="1"/>
+          </p:cNvSpPr>
+          <p:nvPr>
+            <p:ph type="sldImg" idx="2"/>
+          </p:nvPr>
+        </p:nvSpPr>
+        <p:spPr/>
+      </p:sp>
+      <p:sp>
+        <p:nvSpPr>
+          <p:cNvPr id="3" name="Notes Placeholder 2"/>
+          <p:cNvSpPr>
+            <a:spLocks noGrp="1"/>
+          </p:cNvSpPr>
+          <p:nvPr>
+            <p:ph type="body" idx="3" sz="quarter"/>
+          </p:nvPr>
+        </p:nvSpPr>
+        <p:spPr/>
+        <p:txBody>
+          <a:bodyPr/>
+          <a:lstStyle/>
+          <a:p>
+            <a:r>
+              <a:t>Cloud-top height is our strongest result. Over the Antarctic in daylight the median bias is a quarter of a kilometre - the thermal 11-micron retrieval holds up in the polar regime. The Arctic, in polar night in December, is about four times worse at minus 0.95 km; that's a night-versus-day and winter-sea-ice contrast, not something about the pole itself. Worth flagging: the often-quoted minus 0.57 km 'polar' number is really a blend of these two very different regimes, so I prefer to quote them split.</a:t>
+            </a:r>
+          </a:p>
+        </p:txBody>
+      </p:sp>
+      <p:sp>
+        <p:nvSpPr>
+          <p:cNvPr id="4" name="Slide Number Placeholder 3"/>
+          <p:cNvSpPr>
+            <a:spLocks noGrp="1"/>
+          </p:cNvSpPr>
+          <p:nvPr>
+            <p:ph type="sldNum" idx="5" sz="quarter"/>
+          </p:nvPr>
+        </p:nvSpPr>
+        <p:spPr/>
+      </p:sp>
+    </p:spTree>
+  </p:cSld>
+  <p:clrMapOvr>
+    <a:masterClrMapping/>
+  </p:clrMapOvr>
+</p:notes>
+</file>
+
+<file path=ppt/notesSlides/notesSlide5.xml><?xml version="1.0" encoding="utf-8"?>
+<p:notes xmlns:a="http://schemas.openxmlformats.org/drawingml/2006/main" xmlns:p="http://schemas.openxmlformats.org/presentationml/2006/main" xmlns:r="http://schemas.openxmlformats.org/officeDocument/2006/relationships">
+  <p:cSld>
+    <p:spTree>
+      <p:nvGrpSpPr>
+        <p:cNvPr id="1" name=""/>
+        <p:cNvGrpSpPr/>
+        <p:nvPr/>
+      </p:nvGrpSpPr>
+      <p:grpSpPr>
+        <a:xfrm>
+          <a:off x="0" y="0"/>
+          <a:ext cx="0" cy="0"/>
+          <a:chOff x="0" y="0"/>
+          <a:chExt cx="0" cy="0"/>
+        </a:xfrm>
+      </p:grpSpPr>
+      <p:sp>
+        <p:nvSpPr>
+          <p:cNvPr id="2" name="Slide Image Placeholder 1"/>
+          <p:cNvSpPr>
+            <a:spLocks noGrp="1"/>
+          </p:cNvSpPr>
+          <p:nvPr>
+            <p:ph type="sldImg" idx="2"/>
+          </p:nvPr>
+        </p:nvSpPr>
+        <p:spPr/>
+      </p:sp>
+      <p:sp>
+        <p:nvSpPr>
+          <p:cNvPr id="3" name="Notes Placeholder 2"/>
+          <p:cNvSpPr>
+            <a:spLocks noGrp="1"/>
+          </p:cNvSpPr>
+          <p:nvPr>
+            <p:ph type="body" idx="3" sz="quarter"/>
+          </p:nvPr>
+        </p:nvSpPr>
+        <p:spPr/>
+        <p:txBody>
+          <a:bodyPr/>
+          <a:lstStyle/>
+          <a:p>
+            <a:r>
+              <a:t>Water-cloud optical depth. First a methodological point: report the median, not the mean. Optical depth is heavy-tailed, and the mean gets dragged positive by a few thick-cloud pixels - it even flips sign. On the median, ORAC underestimates by about 5. The cause is saturation: ORAC's passive liquid optical depth is stuck around 5 to 8 across the whole reference range, from below 1 up to 34. So it over-reads thin cloud, saturates on thick cloud, and can't correlate. And it's genuinely ORAC saturating - using the radar in the reference changes the answer by only about 1, so the reference isn't the problem.</a:t>
+            </a:r>
+          </a:p>
+        </p:txBody>
+      </p:sp>
+      <p:sp>
+        <p:nvSpPr>
+          <p:cNvPr id="4" name="Slide Number Placeholder 3"/>
+          <p:cNvSpPr>
+            <a:spLocks noGrp="1"/>
+          </p:cNvSpPr>
+          <p:nvPr>
+            <p:ph type="sldNum" idx="5" sz="quarter"/>
+          </p:nvPr>
+        </p:nvSpPr>
+        <p:spPr/>
+      </p:sp>
+    </p:spTree>
+  </p:cSld>
+  <p:clrMapOvr>
+    <a:masterClrMapping/>
+  </p:clrMapOvr>
+</p:notes>
+</file>
+
+<file path=ppt/notesSlides/notesSlide6.xml><?xml version="1.0" encoding="utf-8"?>
+<p:notes xmlns:a="http://schemas.openxmlformats.org/drawingml/2006/main" xmlns:p="http://schemas.openxmlformats.org/presentationml/2006/main" xmlns:r="http://schemas.openxmlformats.org/officeDocument/2006/relationships">
+  <p:cSld>
+    <p:spTree>
+      <p:nvGrpSpPr>
+        <p:cNvPr id="1" name=""/>
+        <p:cNvGrpSpPr/>
+        <p:nvPr/>
+      </p:nvGrpSpPr>
+      <p:grpSpPr>
+        <a:xfrm>
+          <a:off x="0" y="0"/>
+          <a:ext cx="0" cy="0"/>
+          <a:chOff x="0" y="0"/>
+          <a:chExt cx="0" cy="0"/>
+        </a:xfrm>
+      </p:grpSpPr>
+      <p:sp>
+        <p:nvSpPr>
+          <p:cNvPr id="2" name="Slide Image Placeholder 1"/>
+          <p:cNvSpPr>
+            <a:spLocks noGrp="1"/>
+          </p:cNvSpPr>
+          <p:nvPr>
+            <p:ph type="sldImg" idx="2"/>
+          </p:nvPr>
+        </p:nvSpPr>
+        <p:spPr/>
+      </p:sp>
+      <p:sp>
+        <p:nvSpPr>
+          <p:cNvPr id="3" name="Notes Placeholder 2"/>
+          <p:cNvSpPr>
+            <a:spLocks noGrp="1"/>
+          </p:cNvSpPr>
+          <p:nvPr>
+            <p:ph type="body" idx="3" sz="quarter"/>
+          </p:nvPr>
+        </p:nvSpPr>
+        <p:spPr/>
+        <p:txBody>
+          <a:bodyPr/>
+          <a:lstStyle/>
+          <a:p>
+            <a:r>
+              <a:t>This is the key slide for the cause. If we split by surface type, water optical depth only behaves like a working retrieval - positive correlation, slight over-read - over open water. The instant the surface is sea-ice or ice-sheet, which is 95% of the scene, the correlation collapses to zero and it under-reads by 4 to 5. Same clouds, only the background changed - so the saturation is a bright-surface radiative effect, not a bug. And note the contrast: effective radius stays accurate over the cryosphere, so droplet size is trustworthy even where optical depth isn't.</a:t>
+            </a:r>
+          </a:p>
+        </p:txBody>
+      </p:sp>
+      <p:sp>
+        <p:nvSpPr>
+          <p:cNvPr id="4" name="Slide Number Placeholder 3"/>
+          <p:cNvSpPr>
+            <a:spLocks noGrp="1"/>
+          </p:cNvSpPr>
+          <p:nvPr>
+            <p:ph type="sldNum" idx="5" sz="quarter"/>
+          </p:nvPr>
+        </p:nvSpPr>
+        <p:spPr/>
+      </p:sp>
+    </p:spTree>
+  </p:cSld>
+  <p:clrMapOvr>
+    <a:masterClrMapping/>
+  </p:clrMapOvr>
+</p:notes>
+</file>
+
+<file path=ppt/notesSlides/notesSlide7.xml><?xml version="1.0" encoding="utf-8"?>
+<p:notes xmlns:a="http://schemas.openxmlformats.org/drawingml/2006/main" xmlns:p="http://schemas.openxmlformats.org/presentationml/2006/main" xmlns:r="http://schemas.openxmlformats.org/officeDocument/2006/relationships">
+  <p:cSld>
+    <p:spTree>
+      <p:nvGrpSpPr>
+        <p:cNvPr id="1" name=""/>
+        <p:cNvGrpSpPr/>
+        <p:nvPr/>
+      </p:nvGrpSpPr>
+      <p:grpSpPr>
+        <a:xfrm>
+          <a:off x="0" y="0"/>
+          <a:ext cx="0" cy="0"/>
+          <a:chOff x="0" y="0"/>
+          <a:chExt cx="0" cy="0"/>
+        </a:xfrm>
+      </p:grpSpPr>
+      <p:sp>
+        <p:nvSpPr>
+          <p:cNvPr id="2" name="Slide Image Placeholder 1"/>
+          <p:cNvSpPr>
+            <a:spLocks noGrp="1"/>
+          </p:cNvSpPr>
+          <p:nvPr>
+            <p:ph type="sldImg" idx="2"/>
+          </p:nvPr>
+        </p:nvSpPr>
+        <p:spPr/>
+      </p:sp>
+      <p:sp>
+        <p:nvSpPr>
+          <p:cNvPr id="3" name="Notes Placeholder 2"/>
+          <p:cNvSpPr>
+            <a:spLocks noGrp="1"/>
+          </p:cNvSpPr>
+          <p:nvPr>
+            <p:ph type="body" idx="3" sz="quarter"/>
+          </p:nvPr>
+        </p:nvSpPr>
+        <p:spPr/>
+        <p:txBody>
+          <a:bodyPr/>
+          <a:lstStyle/>
+          <a:p>
+            <a:r>
+              <a:t>Does the optical-depth problem matter for the water budget? Yes. ORAC's liquid water path runs about a third low on the median, decorrelated, and worse over the ice sheet. What makes this convincing is the reference: we integrated EarthCARE's radar-plus-lidar liquid water content, a measurement that never uses optical depth - so it independently confirms the saturation propagates into the water path. Same fix required: better handling of the bright surface albedo.</a:t>
+            </a:r>
+          </a:p>
+        </p:txBody>
+      </p:sp>
+      <p:sp>
+        <p:nvSpPr>
+          <p:cNvPr id="4" name="Slide Number Placeholder 3"/>
+          <p:cNvSpPr>
+            <a:spLocks noGrp="1"/>
+          </p:cNvSpPr>
+          <p:nvPr>
+            <p:ph type="sldNum" idx="5" sz="quarter"/>
+          </p:nvPr>
+        </p:nvSpPr>
+        <p:spPr/>
+      </p:sp>
+    </p:spTree>
+  </p:cSld>
+  <p:clrMapOvr>
+    <a:masterClrMapping/>
+  </p:clrMapOvr>
+</p:notes>
+</file>
+
+<file path=ppt/notesSlides/notesSlide8.xml><?xml version="1.0" encoding="utf-8"?>
+<p:notes xmlns:a="http://schemas.openxmlformats.org/drawingml/2006/main" xmlns:p="http://schemas.openxmlformats.org/presentationml/2006/main" xmlns:r="http://schemas.openxmlformats.org/officeDocument/2006/relationships">
+  <p:cSld>
+    <p:spTree>
+      <p:nvGrpSpPr>
+        <p:cNvPr id="1" name=""/>
+        <p:cNvGrpSpPr/>
+        <p:nvPr/>
+      </p:nvGrpSpPr>
+      <p:grpSpPr>
+        <a:xfrm>
+          <a:off x="0" y="0"/>
+          <a:ext cx="0" cy="0"/>
+          <a:chOff x="0" y="0"/>
+          <a:chExt cx="0" cy="0"/>
+        </a:xfrm>
+      </p:grpSpPr>
+      <p:sp>
+        <p:nvSpPr>
+          <p:cNvPr id="2" name="Slide Image Placeholder 1"/>
+          <p:cNvSpPr>
+            <a:spLocks noGrp="1"/>
+          </p:cNvSpPr>
+          <p:nvPr>
+            <p:ph type="sldImg" idx="2"/>
+          </p:nvPr>
+        </p:nvSpPr>
+        <p:spPr/>
+      </p:sp>
+      <p:sp>
+        <p:nvSpPr>
+          <p:cNvPr id="3" name="Notes Placeholder 2"/>
+          <p:cNvSpPr>
+            <a:spLocks noGrp="1"/>
+          </p:cNvSpPr>
+          <p:nvPr>
+            <p:ph type="body" idx="3" sz="quarter"/>
+          </p:nvPr>
+        </p:nvSpPr>
+        <p:spPr/>
+        <p:txBody>
+          <a:bodyPr/>
+          <a:lstStyle/>
+          <a:p>
+            <a:r>
+              <a:t>The categorical validation, and the part that's new since last time. Against A-TC, which classifies every lidar bin, we can finally score both phases. Liquid detection is good at about 90%, but ice detection is only 62% - ORAC calls 38% of ice cloud tops liquid. That's a liquid bias. Crucially it's surface-independent - 62 to 64% over open water, sea-ice and ice-sheet alike - so it's a different, intrinsic limitation, separate from the surface-driven saturation. On the cloud mask, ORAC is conservative: it catches 69% with a low false-alarm rate, and what it misses is 88% thin cirrus that the lidar sees and a passive imager physically cannot. Read POD as: of all the real ice clouds, what fraction did ORAC catch.</a:t>
+            </a:r>
+          </a:p>
+        </p:txBody>
+      </p:sp>
+      <p:sp>
+        <p:nvSpPr>
+          <p:cNvPr id="4" name="Slide Number Placeholder 3"/>
+          <p:cNvSpPr>
+            <a:spLocks noGrp="1"/>
+          </p:cNvSpPr>
+          <p:nvPr>
+            <p:ph type="sldNum" idx="5" sz="quarter"/>
+          </p:nvPr>
+        </p:nvSpPr>
+        <p:spPr/>
+      </p:sp>
+    </p:spTree>
+  </p:cSld>
+  <p:clrMapOvr>
+    <a:masterClrMapping/>
+  </p:clrMapOvr>
+</p:notes>
+</file>
+
+<file path=ppt/notesSlides/notesSlide9.xml><?xml version="1.0" encoding="utf-8"?>
+<p:notes xmlns:a="http://schemas.openxmlformats.org/drawingml/2006/main" xmlns:p="http://schemas.openxmlformats.org/presentationml/2006/main" xmlns:r="http://schemas.openxmlformats.org/officeDocument/2006/relationships">
+  <p:cSld>
+    <p:spTree>
+      <p:nvGrpSpPr>
+        <p:cNvPr id="1" name=""/>
+        <p:cNvGrpSpPr/>
+        <p:nvPr/>
+      </p:nvGrpSpPr>
+      <p:grpSpPr>
+        <a:xfrm>
+          <a:off x="0" y="0"/>
+          <a:ext cx="0" cy="0"/>
+          <a:chOff x="0" y="0"/>
+          <a:chExt cx="0" cy="0"/>
+        </a:xfrm>
+      </p:grpSpPr>
+      <p:sp>
+        <p:nvSpPr>
+          <p:cNvPr id="2" name="Slide Image Placeholder 1"/>
+          <p:cNvSpPr>
+            <a:spLocks noGrp="1"/>
+          </p:cNvSpPr>
+          <p:nvPr>
+            <p:ph type="sldImg" idx="2"/>
+          </p:nvPr>
+        </p:nvSpPr>
+        <p:spPr/>
+      </p:sp>
+      <p:sp>
+        <p:nvSpPr>
+          <p:cNvPr id="3" name="Notes Placeholder 2"/>
+          <p:cNvSpPr>
+            <a:spLocks noGrp="1"/>
+          </p:cNvSpPr>
+          <p:nvPr>
+            <p:ph type="body" idx="3" sz="quarter"/>
+          </p:nvPr>
+        </p:nvSpPr>
+        <p:spPr/>
+        <p:txBody>
+          <a:bodyPr/>
+          <a:lstStyle/>
+          <a:p>
+            <a:r>
+              <a:t>A one-look summary of every variable. The green rows are trustworthy - cloud-top height and effective radius, plus a conservative cloud mask. The amber rows are regime-limited - the optical depths and the water path, all tied to the same saturation. The red row is the phase, our clearest weakness. If you take one thing from this table: the thermal and microphysical-shape products are solid; the solar optical-depth magnitude and the phase are where the work is.</a:t>
+            </a:r>
+          </a:p>
+        </p:txBody>
+      </p:sp>
+      <p:sp>
+        <p:nvSpPr>
+          <p:cNvPr id="4" name="Slide Number Placeholder 3"/>
+          <p:cNvSpPr>
+            <a:spLocks noGrp="1"/>
+          </p:cNvSpPr>
+          <p:nvPr>
+            <p:ph type="sldNum" idx="5" sz="quarter"/>
+          </p:nvPr>
+        </p:nvSpPr>
+        <p:spPr/>
+      </p:sp>
+    </p:spTree>
+  </p:cSld>
+  <p:clrMapOvr>
+    <a:masterClrMapping/>
+  </p:clrMapOvr>
+</p:notes>
 </file>
 
 <file path=ppt/slideLayouts/slideLayout1.xml><?xml version="1.0" encoding="utf-8"?>
@@ -3223,7 +4274,7 @@
 </p:sld>
 </file>
 
-<file path=ppt/slides/slide2.xml><?xml version="1.0" encoding="utf-8"?>
+<file path=ppt/slides/slide10.xml><?xml version="1.0" encoding="utf-8"?>
 <p:sld xmlns:a="http://schemas.openxmlformats.org/drawingml/2006/main" xmlns:p="http://schemas.openxmlformats.org/presentationml/2006/main" xmlns:r="http://schemas.openxmlformats.org/officeDocument/2006/relationships">
   <p:cSld>
     <p:spTree>
@@ -3261,7 +4312,7 @@
                   <a:srgbClr val="1B4F72"/>
                 </a:solidFill>
               </a:rPr>
-              <a:t>Scope &amp; collocation — a polar comparison by orbital mechanics</a:t>
+              <a:t>Summary — what is validated, and what is next</a:t>
             </a:r>
           </a:p>
           <a:p>
@@ -3271,7 +4322,7 @@
                   <a:srgbClr val="555555"/>
                 </a:solidFill>
               </a:rPr>
-              <a:t>Simultaneous-nadir-overpass geometry of two sun-synchronous orbiters</a:t>
+              <a:t>Every EarthCARE-validatable dimension of the Dec-2025 sample is complete</a:t>
             </a:r>
           </a:p>
         </p:txBody>
@@ -3319,40 +4370,16 @@
           </a:p>
         </p:txBody>
       </p:sp>
-      <p:pic>
-        <p:nvPicPr>
-          <p:cNvPr id="4" name="Picture 3" descr="collocation_map_polar.png"/>
-          <p:cNvPicPr>
-            <a:picLocks noChangeAspect="1"/>
-          </p:cNvPicPr>
+      <p:sp>
+        <p:nvSpPr>
+          <p:cNvPr id="4" name="TextBox 3"/>
+          <p:cNvSpPr txBox="1"/>
           <p:nvPr/>
-        </p:nvPicPr>
-        <p:blipFill>
-          <a:blip r:embed="rId2"/>
-          <a:stretch>
-            <a:fillRect/>
-          </a:stretch>
-        </p:blipFill>
+        </p:nvSpPr>
         <p:spPr>
           <a:xfrm>
-            <a:off x="2162583" y="1280160"/>
-            <a:ext cx="7866529" cy="3566160"/>
-          </a:xfrm>
-          <a:prstGeom prst="rect">
-            <a:avLst/>
-          </a:prstGeom>
-        </p:spPr>
-      </p:pic>
-      <p:sp>
-        <p:nvSpPr>
-          <p:cNvPr id="5" name="TextBox 4"/>
-          <p:cNvSpPr txBox="1"/>
-          <p:nvPr/>
-        </p:nvSpPr>
-        <p:spPr>
-          <a:xfrm>
-            <a:off x="640080" y="5029200"/>
-            <a:ext cx="10972800" cy="1737360"/>
+            <a:off x="640080" y="1371600"/>
+            <a:ext cx="10972800" cy="5120640"/>
           </a:xfrm>
           <a:prstGeom prst="rect">
             <a:avLst/>
@@ -3371,12 +4398,27 @@
               </a:spcAft>
             </a:pPr>
             <a:r>
-              <a:rPr sz="1500" b="1">
+              <a:rPr sz="1700" b="1">
                 <a:solidFill>
                   <a:srgbClr val="1B4F72"/>
                 </a:solidFill>
               </a:rPr>
-              <a:t>• SLSTR and EarthCARE are both sun-synchronous → their tracks coincide only near the poles (~70–83°). Every match is polar — not a choice.</a:t>
+              <a:t>• VALIDATED (all median-primary, with confidence intervals):</a:t>
+            </a:r>
+          </a:p>
+          <a:p>
+            <a:pPr lvl="1">
+              <a:spcAft>
+                <a:spcPts val="600"/>
+              </a:spcAft>
+            </a:pPr>
+            <a:r>
+              <a:rPr sz="1500" b="0">
+                <a:solidFill>
+                  <a:srgbClr val="222222"/>
+                </a:solidFill>
+              </a:rPr>
+              <a:t>– CTH · water-COT · ice-COT · CER · CWP · cloud mask · phase — plus collocation methodology, surface-type &amp; phase stratification.</a:t>
             </a:r>
           </a:p>
           <a:p>
@@ -3386,12 +4428,57 @@
               </a:spcAft>
             </a:pPr>
             <a:r>
+              <a:rPr sz="1700" b="1">
+                <a:solidFill>
+                  <a:srgbClr val="1B4F72"/>
+                </a:solidFill>
+              </a:rPr>
+              <a:t>• THE UNIFYING STORY — two independent limitations of the polar-daytime solar retrieval:</a:t>
+            </a:r>
+          </a:p>
+          <a:p>
+            <a:pPr lvl="1">
+              <a:spcAft>
+                <a:spcPts val="600"/>
+              </a:spcAft>
+            </a:pPr>
+            <a:r>
               <a:rPr sz="1500" b="0">
                 <a:solidFill>
                   <a:srgbClr val="222222"/>
                 </a:solidFill>
               </a:rPr>
-              <a:t>• Match: temporal gate ±60 min + nearest pixel &lt; 3 km (SLSTR ≈ EarthCARE ≈ 1 km footprint).</a:t>
+              <a:t>– (1) bright-surface optical-depth SATURATION (surface-driven; propagates into CWP; spares open water),</a:t>
+            </a:r>
+          </a:p>
+          <a:p>
+            <a:pPr lvl="1">
+              <a:spcAft>
+                <a:spcPts val="600"/>
+              </a:spcAft>
+            </a:pPr>
+            <a:r>
+              <a:rPr sz="1500" b="0">
+                <a:solidFill>
+                  <a:srgbClr val="222222"/>
+                </a:solidFill>
+              </a:rPr>
+              <a:t>– (2) an intrinsic LIQUID PHASE BIAS (POD_ice 62%; surface-independent).</a:t>
+            </a:r>
+          </a:p>
+          <a:p>
+            <a:pPr lvl="1">
+              <a:spcAft>
+                <a:spcPts val="600"/>
+              </a:spcAft>
+            </a:pPr>
+            <a:r>
+              <a:rPr sz="1500" b="0">
+                <a:solidFill>
+                  <a:srgbClr val="222222"/>
+                </a:solidFill>
+              </a:rPr>
+              <a:t>– Thermal CTH is strong (−0.25 km); CER is robust. These are the trustworthy products over the cryosphere.</a:t>
             </a:r>
           </a:p>
           <a:p>
@@ -3401,16 +4488,16 @@
               </a:spcAft>
             </a:pPr>
             <a:r>
-              <a:rPr sz="1500" b="0">
-                <a:solidFill>
-                  <a:srgbClr val="222222"/>
+              <a:rPr sz="1700" b="1">
+                <a:solidFill>
+                  <a:srgbClr val="1B4F72"/>
                 </a:solidFill>
               </a:rPr>
-              <a:t>• Solar retrievals need daylight → December = Antarctic polar day → the COT/CER/CWP/phase sample is 100% Southern Hemisphere; thermal CTH also samples the Arctic (night).</a:t>
-            </a:r>
-          </a:p>
-          <a:p>
-            <a:pPr>
+              <a:t>• NEXT STEPS (require new processing, not further analysis):</a:t>
+            </a:r>
+          </a:p>
+          <a:p>
+            <a:pPr lvl="1">
               <a:spcAft>
                 <a:spcPts val="600"/>
               </a:spcAft>
@@ -3421,7 +4508,7 @@
                   <a:srgbClr val="222222"/>
                 </a:solidFill>
               </a:rPr>
-              <a:t>• References: A-CTH (height) · ACM-CAP (liquid COT/CER, radar+lidar LWP) · A-EBD (ice COT) · A-TC (phase &amp; cloud mask).</a:t>
+              <a:t>– Arctic / boreal-summer month (Arctic sea-ice &amp; Greenland) · Sentinel-3B · other seasons.</a:t>
             </a:r>
           </a:p>
         </p:txBody>
@@ -3434,7 +4521,7 @@
 </p:sld>
 </file>
 
-<file path=ppt/slides/slide3.xml><?xml version="1.0" encoding="utf-8"?>
+<file path=ppt/slides/slide2.xml><?xml version="1.0" encoding="utf-8"?>
 <p:sld xmlns:a="http://schemas.openxmlformats.org/drawingml/2006/main" xmlns:p="http://schemas.openxmlformats.org/presentationml/2006/main" xmlns:r="http://schemas.openxmlformats.org/officeDocument/2006/relationships">
   <p:cSld>
     <p:spTree>
@@ -3472,7 +4559,7 @@
                   <a:srgbClr val="1B4F72"/>
                 </a:solidFill>
               </a:rPr>
-              <a:t>Cloud-top height — the strong result</a:t>
+              <a:t>Progress to date</a:t>
             </a:r>
           </a:p>
           <a:p>
@@ -3482,7 +4569,7 @@
                   <a:srgbClr val="555555"/>
                 </a:solidFill>
               </a:rPr>
-              <a:t>ORAC vs A-CTH, both hemispheres (thermal retrieval works day &amp; night)</a:t>
+              <a:t>From collocation framework to a complete Antarctic-summer validation</a:t>
             </a:r>
           </a:p>
         </p:txBody>
@@ -3530,40 +4617,16 @@
           </a:p>
         </p:txBody>
       </p:sp>
-      <p:pic>
-        <p:nvPicPr>
-          <p:cNvPr id="4" name="Picture 3" descr="cth_scatter.png"/>
-          <p:cNvPicPr>
-            <a:picLocks noChangeAspect="1"/>
-          </p:cNvPicPr>
+      <p:sp>
+        <p:nvSpPr>
+          <p:cNvPr id="4" name="TextBox 3"/>
+          <p:cNvSpPr txBox="1"/>
           <p:nvPr/>
-        </p:nvPicPr>
-        <p:blipFill>
-          <a:blip r:embed="rId2"/>
-          <a:stretch>
-            <a:fillRect/>
-          </a:stretch>
-        </p:blipFill>
+        </p:nvSpPr>
         <p:spPr>
           <a:xfrm>
-            <a:off x="2512846" y="1280160"/>
-            <a:ext cx="7166002" cy="3566160"/>
-          </a:xfrm>
-          <a:prstGeom prst="rect">
-            <a:avLst/>
-          </a:prstGeom>
-        </p:spPr>
-      </p:pic>
-      <p:sp>
-        <p:nvSpPr>
-          <p:cNvPr id="5" name="TextBox 4"/>
-          <p:cNvSpPr txBox="1"/>
-          <p:nvPr/>
-        </p:nvSpPr>
-        <p:spPr>
-          <a:xfrm>
-            <a:off x="640080" y="5029200"/>
-            <a:ext cx="10972800" cy="1737360"/>
+            <a:off x="640080" y="1417320"/>
+            <a:ext cx="10972800" cy="4937760"/>
           </a:xfrm>
           <a:prstGeom prst="rect">
             <a:avLst/>
@@ -3582,12 +4645,12 @@
               </a:spcAft>
             </a:pPr>
             <a:r>
-              <a:rPr sz="1500" b="1">
+              <a:rPr sz="1700" b="1">
                 <a:solidFill>
                   <a:srgbClr val="1B4F72"/>
                 </a:solidFill>
               </a:rPr>
-              <a:t>• Median CTH bias −0.25 km (Antarctic, polar day) — the thermal cloud-top retrieval survives the polar regime.</a:t>
+              <a:t>• Collocation pipeline built &amp; characterised — polar simultaneous-nadir-overpass geometry, ±60 min / 3 km, density map + Δt/distance sensitivity.</a:t>
             </a:r>
           </a:p>
           <a:p>
@@ -3597,12 +4660,12 @@
               </a:spcAft>
             </a:pPr>
             <a:r>
-              <a:rPr sz="1500" b="0">
-                <a:solidFill>
-                  <a:srgbClr val="222222"/>
+              <a:rPr sz="1700" b="1">
+                <a:solidFill>
+                  <a:srgbClr val="1B4F72"/>
                 </a:solidFill>
               </a:rPr>
-              <a:t>• Arctic (polar night) −0.95 km: ~4× larger, a night-vs-day + winter-sea-ice regime contrast, not a pole effect.</a:t>
+              <a:t>• Continuous validation complete — CTH (both hemispheres), water-COT, ice-COT, CER, CWP, all against EarthCARE and median-primary with confidence intervals.</a:t>
             </a:r>
           </a:p>
           <a:p>
@@ -3612,12 +4675,57 @@
               </a:spcAft>
             </a:pPr>
             <a:r>
-              <a:rPr sz="1500" b="0">
+              <a:rPr sz="1700" b="0">
                 <a:solidFill>
                   <a:srgbClr val="222222"/>
                 </a:solidFill>
               </a:rPr>
-              <a:t>• The one variable that samples both hemispheres; the headline −0.57 km 'polar' number blends the two regimes.</a:t>
+              <a:t>• Root cause established — passive τ saturation over bright surfaces; surface-type stratification; independent radar+lidar water-path check.</a:t>
+            </a:r>
+          </a:p>
+          <a:p>
+            <a:pPr>
+              <a:spcAft>
+                <a:spcPts val="600"/>
+              </a:spcAft>
+            </a:pPr>
+            <a:r>
+              <a:rPr sz="1700" b="1">
+                <a:solidFill>
+                  <a:srgbClr val="1B4F72"/>
+                </a:solidFill>
+              </a:rPr>
+              <a:t>• Categorical validation closed — NEW: cloud mask + phase vs A-TC; ice-detection skill (POD_ice) measurable for the first time.</a:t>
+            </a:r>
+          </a:p>
+          <a:p>
+            <a:pPr>
+              <a:spcAft>
+                <a:spcPts val="600"/>
+              </a:spcAft>
+            </a:pPr>
+            <a:r>
+              <a:rPr sz="1700" b="0">
+                <a:solidFill>
+                  <a:srgbClr val="222222"/>
+                </a:solidFill>
+              </a:rPr>
+              <a:t>• Fully written up &amp; reproducible — six variable reports + summary + this deck; all version-controlled.</a:t>
+            </a:r>
+          </a:p>
+          <a:p>
+            <a:pPr>
+              <a:spcAft>
+                <a:spcPts val="600"/>
+              </a:spcAft>
+            </a:pPr>
+            <a:r>
+              <a:rPr sz="1700" b="0">
+                <a:solidFill>
+                  <a:srgbClr val="222222"/>
+                </a:solidFill>
+              </a:rPr>
+              <a:t>• Ready for review — remaining extensions need new processing (Arctic month, Sentinel-3B, other seasons), not further analysis of this sample.</a:t>
             </a:r>
           </a:p>
         </p:txBody>
@@ -3630,7 +4738,7 @@
 </p:sld>
 </file>
 
-<file path=ppt/slides/slide4.xml><?xml version="1.0" encoding="utf-8"?>
+<file path=ppt/slides/slide3.xml><?xml version="1.0" encoding="utf-8"?>
 <p:sld xmlns:a="http://schemas.openxmlformats.org/drawingml/2006/main" xmlns:p="http://schemas.openxmlformats.org/presentationml/2006/main" xmlns:r="http://schemas.openxmlformats.org/officeDocument/2006/relationships">
   <p:cSld>
     <p:spTree>
@@ -3668,7 +4776,7 @@
                   <a:srgbClr val="1B4F72"/>
                 </a:solidFill>
               </a:rPr>
-              <a:t>Water-cloud optical depth — the passive retrieval saturates</a:t>
+              <a:t>Scope &amp; collocation — a polar comparison by orbital mechanics</a:t>
             </a:r>
           </a:p>
           <a:p>
@@ -3678,7 +4786,7 @@
                   <a:srgbClr val="555555"/>
                 </a:solidFill>
               </a:rPr>
-              <a:t>ORAC vs ACM-CAP (radar-aided synergy), phase-agree liquid</a:t>
+              <a:t>Simultaneous-nadir-overpass geometry of two sun-synchronous orbiters</a:t>
             </a:r>
           </a:p>
         </p:txBody>
@@ -3728,7 +4836,7 @@
       </p:sp>
       <p:pic>
         <p:nvPicPr>
-          <p:cNvPr id="4" name="Picture 3" descr="cot_water_saturation.png"/>
+          <p:cNvPr id="4" name="Picture 3" descr="collocation_map_polar.png"/>
           <p:cNvPicPr>
             <a:picLocks noChangeAspect="1"/>
           </p:cNvPicPr>
@@ -3742,8 +4850,8 @@
         </p:blipFill>
         <p:spPr>
           <a:xfrm>
-            <a:off x="1459839" y="1280160"/>
-            <a:ext cx="9272016" cy="3566160"/>
+            <a:off x="2162583" y="1280160"/>
+            <a:ext cx="7866529" cy="3566160"/>
           </a:xfrm>
           <a:prstGeom prst="rect">
             <a:avLst/>
@@ -3783,7 +4891,7 @@
                   <a:srgbClr val="1B4F72"/>
                 </a:solidFill>
               </a:rPr>
-              <a:t>• Report the MEDIAN: −4.8. The quoted '+3 mean' is a skew artefact of a high-τ tail (it even flips sign).</a:t>
+              <a:t>• SLSTR and EarthCARE are both sun-synchronous → their tracks coincide only near the poles (~70–83°). Every match is polar — not a choice.</a:t>
             </a:r>
           </a:p>
           <a:p>
@@ -3798,7 +4906,7 @@
                   <a:srgbClr val="222222"/>
                 </a:solidFill>
               </a:rPr>
-              <a:t>• ORAC's passive liquid τ is pinned ~5–8 across the entire ACM-CAP range (0.6→34): it over-reads thin cloud, saturates on thick, and cannot correlate (r_log ≈ 0.1).</a:t>
+              <a:t>• Match: temporal gate ±60 min + nearest pixel &lt; 3 km (SLSTR ≈ EarthCARE ≈ 1 km footprint).</a:t>
             </a:r>
           </a:p>
           <a:p>
@@ -3813,7 +4921,22 @@
                   <a:srgbClr val="222222"/>
                 </a:solidFill>
               </a:rPr>
-              <a:t>• It is ORAC saturating, not the radar reference being high (CPR changes the bias by ~1 τ).</a:t>
+              <a:t>• Solar retrievals need daylight → December = Antarctic polar day → the COT/CER/CWP/phase sample is 100% Southern Hemisphere; thermal CTH also samples the Arctic (night).</a:t>
+            </a:r>
+          </a:p>
+          <a:p>
+            <a:pPr>
+              <a:spcAft>
+                <a:spcPts val="600"/>
+              </a:spcAft>
+            </a:pPr>
+            <a:r>
+              <a:rPr sz="1500" b="0">
+                <a:solidFill>
+                  <a:srgbClr val="222222"/>
+                </a:solidFill>
+              </a:rPr>
+              <a:t>• References: A-CTH (height) · ACM-CAP (liquid COT/CER, radar+lidar LWP) · A-EBD (ice COT) · A-TC (phase &amp; cloud mask).</a:t>
             </a:r>
           </a:p>
         </p:txBody>
@@ -3826,7 +4949,7 @@
 </p:sld>
 </file>
 
-<file path=ppt/slides/slide5.xml><?xml version="1.0" encoding="utf-8"?>
+<file path=ppt/slides/slide4.xml><?xml version="1.0" encoding="utf-8"?>
 <p:sld xmlns:a="http://schemas.openxmlformats.org/drawingml/2006/main" xmlns:p="http://schemas.openxmlformats.org/presentationml/2006/main" xmlns:r="http://schemas.openxmlformats.org/officeDocument/2006/relationships">
   <p:cSld>
     <p:spTree>
@@ -3864,7 +4987,7 @@
                   <a:srgbClr val="1B4F72"/>
                 </a:solidFill>
               </a:rPr>
-              <a:t>The deficit is cryospheric — the surface, not the phase</a:t>
+              <a:t>Cloud-top height — the strong result</a:t>
             </a:r>
           </a:p>
           <a:p>
@@ -3874,7 +4997,7 @@
                   <a:srgbClr val="555555"/>
                 </a:solidFill>
               </a:rPr>
-              <a:t>Solar-retrieval skill split by ORAC surface type</a:t>
+              <a:t>ORAC vs A-CTH, both hemispheres (thermal retrieval works day &amp; night)</a:t>
             </a:r>
           </a:p>
         </p:txBody>
@@ -3924,7 +5047,7 @@
       </p:sp>
       <p:pic>
         <p:nvPicPr>
-          <p:cNvPr id="4" name="Picture 3" descr="surface_type_bias.png"/>
+          <p:cNvPr id="4" name="Picture 3" descr="cth_scatter.png"/>
           <p:cNvPicPr>
             <a:picLocks noChangeAspect="1"/>
           </p:cNvPicPr>
@@ -3938,8 +5061,8 @@
         </p:blipFill>
         <p:spPr>
           <a:xfrm>
-            <a:off x="746607" y="1280160"/>
-            <a:ext cx="10698480" cy="3566160"/>
+            <a:off x="2512846" y="1280160"/>
+            <a:ext cx="7166002" cy="3566160"/>
           </a:xfrm>
           <a:prstGeom prst="rect">
             <a:avLst/>
@@ -3979,7 +5102,7 @@
                   <a:srgbClr val="1B4F72"/>
                 </a:solidFill>
               </a:rPr>
-              <a:t>• Water-COT correlates (r = +0.28) and over-reads ONLY over open water; over sea-ice &amp; ice-sheet (95% of the scene) r → 0 and bias is −4 to −5.</a:t>
+              <a:t>• Median CTH bias −0.25 km (Antarctic, polar day) — the thermal cloud-top retrieval survives the polar regime.</a:t>
             </a:r>
           </a:p>
           <a:p>
@@ -3994,7 +5117,7 @@
                   <a:srgbClr val="222222"/>
                 </a:solidFill>
               </a:rPr>
-              <a:t>• Same clouds, only the background changed → the τ saturation is the bright-surface radiative regime, not an algorithm bug.</a:t>
+              <a:t>• Arctic (polar night) −0.95 km: ~4× larger, a night-vs-day + winter-sea-ice regime contrast, not a pole effect.</a:t>
             </a:r>
           </a:p>
           <a:p>
@@ -4009,7 +5132,7 @@
                   <a:srgbClr val="222222"/>
                 </a:solidFill>
               </a:rPr>
-              <a:t>• CER is surface-robust (median +0.2 / +0.3 µm over sea-ice / ice-sheet): trustworthy droplet size even where τ is unconstrained.</a:t>
+              <a:t>• The one variable that samples both hemispheres; the headline −0.57 km 'polar' number blends the two regimes.</a:t>
             </a:r>
           </a:p>
         </p:txBody>
@@ -4022,7 +5145,7 @@
 </p:sld>
 </file>
 
-<file path=ppt/slides/slide6.xml><?xml version="1.0" encoding="utf-8"?>
+<file path=ppt/slides/slide5.xml><?xml version="1.0" encoding="utf-8"?>
 <p:sld xmlns:a="http://schemas.openxmlformats.org/drawingml/2006/main" xmlns:p="http://schemas.openxmlformats.org/presentationml/2006/main" xmlns:r="http://schemas.openxmlformats.org/officeDocument/2006/relationships">
   <p:cSld>
     <p:spTree>
@@ -4060,7 +5183,7 @@
                   <a:srgbClr val="1B4F72"/>
                 </a:solidFill>
               </a:rPr>
-              <a:t>Liquid water path — the saturation reaches the water budget</a:t>
+              <a:t>Water-cloud optical depth — the passive retrieval saturates</a:t>
             </a:r>
           </a:p>
           <a:p>
@@ -4070,7 +5193,7 @@
                   <a:srgbClr val="555555"/>
                 </a:solidFill>
               </a:rPr>
-              <a:t>ORAC cwp vs an independent ACM-CAP water-content reference (LWP)</a:t>
+              <a:t>ORAC vs ACM-CAP (radar-aided synergy), phase-agree liquid</a:t>
             </a:r>
           </a:p>
         </p:txBody>
@@ -4120,7 +5243,7 @@
       </p:sp>
       <p:pic>
         <p:nvPicPr>
-          <p:cNvPr id="4" name="Picture 3" descr="cwp_validation.png"/>
+          <p:cNvPr id="4" name="Picture 3" descr="cot_water_saturation.png"/>
           <p:cNvPicPr>
             <a:picLocks noChangeAspect="1"/>
           </p:cNvPicPr>
@@ -4134,8 +5257,8 @@
         </p:blipFill>
         <p:spPr>
           <a:xfrm>
-            <a:off x="1981048" y="1280160"/>
-            <a:ext cx="8229599" cy="3566160"/>
+            <a:off x="1459839" y="1280160"/>
+            <a:ext cx="9272016" cy="3566160"/>
           </a:xfrm>
           <a:prstGeom prst="rect">
             <a:avLst/>
@@ -4175,7 +5298,7 @@
                   <a:srgbClr val="1B4F72"/>
                 </a:solidFill>
               </a:rPr>
-              <a:t>• ORAC liquid water path runs 34% low on the median (30 vs 47 g m⁻²), decorrelated, worse over ice sheet (−18) than ocean (−13).</a:t>
+              <a:t>• Report the MEDIAN: −4.8. The quoted '+3 mean' is a skew artefact of a high-τ tail (it even flips sign).</a:t>
             </a:r>
           </a:p>
           <a:p>
@@ -4190,7 +5313,7 @@
                   <a:srgbClr val="222222"/>
                 </a:solidFill>
               </a:rPr>
-              <a:t>• Validated against radar+lidar liquid-water-content — a reference that never sees τ — so it confirms the τ saturation propagates into the water budget.</a:t>
+              <a:t>• ORAC's passive liquid τ is pinned ~5–8 across the entire ACM-CAP range (0.6→34): it over-reads thin cloud, saturates on thick, and cannot correlate (r_log ≈ 0.1).</a:t>
             </a:r>
           </a:p>
           <a:p>
@@ -4205,7 +5328,7 @@
                   <a:srgbClr val="222222"/>
                 </a:solidFill>
               </a:rPr>
-              <a:t>• Fixed by the same surface-albedo advance, not a CWP-specific change.</a:t>
+              <a:t>• It is ORAC saturating, not the radar reference being high (CPR changes the bias by ~1 τ).</a:t>
             </a:r>
           </a:p>
         </p:txBody>
@@ -4218,7 +5341,7 @@
 </p:sld>
 </file>
 
-<file path=ppt/slides/slide7.xml><?xml version="1.0" encoding="utf-8"?>
+<file path=ppt/slides/slide6.xml><?xml version="1.0" encoding="utf-8"?>
 <p:sld xmlns:a="http://schemas.openxmlformats.org/drawingml/2006/main" xmlns:p="http://schemas.openxmlformats.org/presentationml/2006/main" xmlns:r="http://schemas.openxmlformats.org/officeDocument/2006/relationships">
   <p:cSld>
     <p:spTree>
@@ -4256,7 +5379,7 @@
                   <a:srgbClr val="1B4F72"/>
                 </a:solidFill>
               </a:rPr>
-              <a:t>Cloud mask &amp; phase vs EarthCARE A-TC — the two-way contingency</a:t>
+              <a:t>The deficit is cryospheric — the surface, not the phase</a:t>
             </a:r>
           </a:p>
           <a:p>
@@ -4266,7 +5389,7 @@
                   <a:srgbClr val="555555"/>
                 </a:solidFill>
               </a:rPr>
-              <a:t>Categorical validation (POD_ice, previously unmeasurable)</a:t>
+              <a:t>Solar-retrieval skill split by ORAC surface type</a:t>
             </a:r>
           </a:p>
         </p:txBody>
@@ -4316,6 +5439,398 @@
       </p:sp>
       <p:pic>
         <p:nvPicPr>
+          <p:cNvPr id="4" name="Picture 3" descr="surface_type_bias.png"/>
+          <p:cNvPicPr>
+            <a:picLocks noChangeAspect="1"/>
+          </p:cNvPicPr>
+          <p:nvPr/>
+        </p:nvPicPr>
+        <p:blipFill>
+          <a:blip r:embed="rId2"/>
+          <a:stretch>
+            <a:fillRect/>
+          </a:stretch>
+        </p:blipFill>
+        <p:spPr>
+          <a:xfrm>
+            <a:off x="746607" y="1280160"/>
+            <a:ext cx="10698480" cy="3566160"/>
+          </a:xfrm>
+          <a:prstGeom prst="rect">
+            <a:avLst/>
+          </a:prstGeom>
+        </p:spPr>
+      </p:pic>
+      <p:sp>
+        <p:nvSpPr>
+          <p:cNvPr id="5" name="TextBox 4"/>
+          <p:cNvSpPr txBox="1"/>
+          <p:nvPr/>
+        </p:nvSpPr>
+        <p:spPr>
+          <a:xfrm>
+            <a:off x="640080" y="5029200"/>
+            <a:ext cx="10972800" cy="1737360"/>
+          </a:xfrm>
+          <a:prstGeom prst="rect">
+            <a:avLst/>
+          </a:prstGeom>
+          <a:noFill/>
+        </p:spPr>
+        <p:txBody>
+          <a:bodyPr wrap="square">
+            <a:spAutoFit/>
+          </a:bodyPr>
+          <a:lstStyle/>
+          <a:p>
+            <a:pPr>
+              <a:spcAft>
+                <a:spcPts val="600"/>
+              </a:spcAft>
+            </a:pPr>
+            <a:r>
+              <a:rPr sz="1500" b="1">
+                <a:solidFill>
+                  <a:srgbClr val="1B4F72"/>
+                </a:solidFill>
+              </a:rPr>
+              <a:t>• Water-COT correlates (r = +0.28) and over-reads ONLY over open water; over sea-ice &amp; ice-sheet (95% of the scene) r → 0 and bias is −4 to −5.</a:t>
+            </a:r>
+          </a:p>
+          <a:p>
+            <a:pPr>
+              <a:spcAft>
+                <a:spcPts val="600"/>
+              </a:spcAft>
+            </a:pPr>
+            <a:r>
+              <a:rPr sz="1500" b="0">
+                <a:solidFill>
+                  <a:srgbClr val="222222"/>
+                </a:solidFill>
+              </a:rPr>
+              <a:t>• Same clouds, only the background changed → the τ saturation is the bright-surface radiative regime, not an algorithm bug.</a:t>
+            </a:r>
+          </a:p>
+          <a:p>
+            <a:pPr>
+              <a:spcAft>
+                <a:spcPts val="600"/>
+              </a:spcAft>
+            </a:pPr>
+            <a:r>
+              <a:rPr sz="1500" b="0">
+                <a:solidFill>
+                  <a:srgbClr val="222222"/>
+                </a:solidFill>
+              </a:rPr>
+              <a:t>• CER is surface-robust (median +0.2 / +0.3 µm over sea-ice / ice-sheet): trustworthy droplet size even where τ is unconstrained.</a:t>
+            </a:r>
+          </a:p>
+        </p:txBody>
+      </p:sp>
+    </p:spTree>
+  </p:cSld>
+  <p:clrMapOvr>
+    <a:masterClrMapping/>
+  </p:clrMapOvr>
+</p:sld>
+</file>
+
+<file path=ppt/slides/slide7.xml><?xml version="1.0" encoding="utf-8"?>
+<p:sld xmlns:a="http://schemas.openxmlformats.org/drawingml/2006/main" xmlns:p="http://schemas.openxmlformats.org/presentationml/2006/main" xmlns:r="http://schemas.openxmlformats.org/officeDocument/2006/relationships">
+  <p:cSld>
+    <p:spTree>
+      <p:nvGrpSpPr>
+        <p:cNvPr id="1" name=""/>
+        <p:cNvGrpSpPr/>
+        <p:nvPr/>
+      </p:nvGrpSpPr>
+      <p:grpSpPr/>
+      <p:sp>
+        <p:nvSpPr>
+          <p:cNvPr id="2" name="TextBox 1"/>
+          <p:cNvSpPr txBox="1"/>
+          <p:nvPr/>
+        </p:nvSpPr>
+        <p:spPr>
+          <a:xfrm>
+            <a:off x="457200" y="201168"/>
+            <a:ext cx="11247120" cy="868680"/>
+          </a:xfrm>
+          <a:prstGeom prst="rect">
+            <a:avLst/>
+          </a:prstGeom>
+          <a:noFill/>
+        </p:spPr>
+        <p:txBody>
+          <a:bodyPr wrap="square">
+            <a:spAutoFit/>
+          </a:bodyPr>
+          <a:lstStyle/>
+          <a:p>
+            <a:r>
+              <a:rPr sz="2600" b="1">
+                <a:solidFill>
+                  <a:srgbClr val="1B4F72"/>
+                </a:solidFill>
+              </a:rPr>
+              <a:t>Liquid water path — the saturation reaches the water budget</a:t>
+            </a:r>
+          </a:p>
+          <a:p>
+            <a:r>
+              <a:rPr sz="1400" i="1">
+                <a:solidFill>
+                  <a:srgbClr val="555555"/>
+                </a:solidFill>
+              </a:rPr>
+              <a:t>ORAC cwp vs an independent ACM-CAP water-content reference (LWP)</a:t>
+            </a:r>
+          </a:p>
+        </p:txBody>
+      </p:sp>
+      <p:sp>
+        <p:nvSpPr>
+          <p:cNvPr id="3" name="Rectangle 2"/>
+          <p:cNvSpPr/>
+          <p:nvPr/>
+        </p:nvSpPr>
+        <p:spPr>
+          <a:xfrm>
+            <a:off x="457200" y="1078992"/>
+            <a:ext cx="11247120" cy="31750"/>
+          </a:xfrm>
+          <a:prstGeom prst="rect">
+            <a:avLst/>
+          </a:prstGeom>
+          <a:solidFill>
+            <a:srgbClr val="2E6DA4"/>
+          </a:solidFill>
+          <a:ln>
+            <a:noFill/>
+          </a:ln>
+        </p:spPr>
+        <p:style>
+          <a:lnRef idx="1">
+            <a:schemeClr val="accent1"/>
+          </a:lnRef>
+          <a:fillRef idx="3">
+            <a:schemeClr val="accent1"/>
+          </a:fillRef>
+          <a:effectRef idx="2">
+            <a:schemeClr val="accent1"/>
+          </a:effectRef>
+          <a:fontRef idx="minor">
+            <a:schemeClr val="lt1"/>
+          </a:fontRef>
+        </p:style>
+        <p:txBody>
+          <a:bodyPr rtlCol="0" anchor="ctr"/>
+          <a:lstStyle/>
+          <a:p>
+            <a:pPr algn="ctr"/>
+          </a:p>
+        </p:txBody>
+      </p:sp>
+      <p:pic>
+        <p:nvPicPr>
+          <p:cNvPr id="4" name="Picture 3" descr="cwp_validation.png"/>
+          <p:cNvPicPr>
+            <a:picLocks noChangeAspect="1"/>
+          </p:cNvPicPr>
+          <p:nvPr/>
+        </p:nvPicPr>
+        <p:blipFill>
+          <a:blip r:embed="rId2"/>
+          <a:stretch>
+            <a:fillRect/>
+          </a:stretch>
+        </p:blipFill>
+        <p:spPr>
+          <a:xfrm>
+            <a:off x="1981048" y="1280160"/>
+            <a:ext cx="8229599" cy="3566160"/>
+          </a:xfrm>
+          <a:prstGeom prst="rect">
+            <a:avLst/>
+          </a:prstGeom>
+        </p:spPr>
+      </p:pic>
+      <p:sp>
+        <p:nvSpPr>
+          <p:cNvPr id="5" name="TextBox 4"/>
+          <p:cNvSpPr txBox="1"/>
+          <p:nvPr/>
+        </p:nvSpPr>
+        <p:spPr>
+          <a:xfrm>
+            <a:off x="640080" y="5029200"/>
+            <a:ext cx="10972800" cy="1737360"/>
+          </a:xfrm>
+          <a:prstGeom prst="rect">
+            <a:avLst/>
+          </a:prstGeom>
+          <a:noFill/>
+        </p:spPr>
+        <p:txBody>
+          <a:bodyPr wrap="square">
+            <a:spAutoFit/>
+          </a:bodyPr>
+          <a:lstStyle/>
+          <a:p>
+            <a:pPr>
+              <a:spcAft>
+                <a:spcPts val="600"/>
+              </a:spcAft>
+            </a:pPr>
+            <a:r>
+              <a:rPr sz="1500" b="1">
+                <a:solidFill>
+                  <a:srgbClr val="1B4F72"/>
+                </a:solidFill>
+              </a:rPr>
+              <a:t>• ORAC liquid water path runs 34% low on the median (30 vs 47 g m⁻²), decorrelated, worse over ice sheet (−18) than ocean (−13).</a:t>
+            </a:r>
+          </a:p>
+          <a:p>
+            <a:pPr>
+              <a:spcAft>
+                <a:spcPts val="600"/>
+              </a:spcAft>
+            </a:pPr>
+            <a:r>
+              <a:rPr sz="1500" b="0">
+                <a:solidFill>
+                  <a:srgbClr val="222222"/>
+                </a:solidFill>
+              </a:rPr>
+              <a:t>• Validated against radar+lidar liquid-water-content — a reference that never sees τ — so it confirms the τ saturation propagates into the water budget.</a:t>
+            </a:r>
+          </a:p>
+          <a:p>
+            <a:pPr>
+              <a:spcAft>
+                <a:spcPts val="600"/>
+              </a:spcAft>
+            </a:pPr>
+            <a:r>
+              <a:rPr sz="1500" b="0">
+                <a:solidFill>
+                  <a:srgbClr val="222222"/>
+                </a:solidFill>
+              </a:rPr>
+              <a:t>• Fixed by the same surface-albedo advance, not a CWP-specific change.</a:t>
+            </a:r>
+          </a:p>
+        </p:txBody>
+      </p:sp>
+    </p:spTree>
+  </p:cSld>
+  <p:clrMapOvr>
+    <a:masterClrMapping/>
+  </p:clrMapOvr>
+</p:sld>
+</file>
+
+<file path=ppt/slides/slide8.xml><?xml version="1.0" encoding="utf-8"?>
+<p:sld xmlns:a="http://schemas.openxmlformats.org/drawingml/2006/main" xmlns:p="http://schemas.openxmlformats.org/presentationml/2006/main" xmlns:r="http://schemas.openxmlformats.org/officeDocument/2006/relationships">
+  <p:cSld>
+    <p:spTree>
+      <p:nvGrpSpPr>
+        <p:cNvPr id="1" name=""/>
+        <p:cNvGrpSpPr/>
+        <p:nvPr/>
+      </p:nvGrpSpPr>
+      <p:grpSpPr/>
+      <p:sp>
+        <p:nvSpPr>
+          <p:cNvPr id="2" name="TextBox 1"/>
+          <p:cNvSpPr txBox="1"/>
+          <p:nvPr/>
+        </p:nvSpPr>
+        <p:spPr>
+          <a:xfrm>
+            <a:off x="457200" y="201168"/>
+            <a:ext cx="11247120" cy="868680"/>
+          </a:xfrm>
+          <a:prstGeom prst="rect">
+            <a:avLst/>
+          </a:prstGeom>
+          <a:noFill/>
+        </p:spPr>
+        <p:txBody>
+          <a:bodyPr wrap="square">
+            <a:spAutoFit/>
+          </a:bodyPr>
+          <a:lstStyle/>
+          <a:p>
+            <a:r>
+              <a:rPr sz="2600" b="1">
+                <a:solidFill>
+                  <a:srgbClr val="1B4F72"/>
+                </a:solidFill>
+              </a:rPr>
+              <a:t>Cloud mask &amp; phase vs EarthCARE A-TC — the two-way contingency</a:t>
+            </a:r>
+          </a:p>
+          <a:p>
+            <a:r>
+              <a:rPr sz="1400" i="1">
+                <a:solidFill>
+                  <a:srgbClr val="555555"/>
+                </a:solidFill>
+              </a:rPr>
+              <a:t>Categorical validation (POD_ice, previously unmeasurable)</a:t>
+            </a:r>
+          </a:p>
+        </p:txBody>
+      </p:sp>
+      <p:sp>
+        <p:nvSpPr>
+          <p:cNvPr id="3" name="Rectangle 2"/>
+          <p:cNvSpPr/>
+          <p:nvPr/>
+        </p:nvSpPr>
+        <p:spPr>
+          <a:xfrm>
+            <a:off x="457200" y="1078992"/>
+            <a:ext cx="11247120" cy="31750"/>
+          </a:xfrm>
+          <a:prstGeom prst="rect">
+            <a:avLst/>
+          </a:prstGeom>
+          <a:solidFill>
+            <a:srgbClr val="2E6DA4"/>
+          </a:solidFill>
+          <a:ln>
+            <a:noFill/>
+          </a:ln>
+        </p:spPr>
+        <p:style>
+          <a:lnRef idx="1">
+            <a:schemeClr val="accent1"/>
+          </a:lnRef>
+          <a:fillRef idx="3">
+            <a:schemeClr val="accent1"/>
+          </a:fillRef>
+          <a:effectRef idx="2">
+            <a:schemeClr val="accent1"/>
+          </a:effectRef>
+          <a:fontRef idx="minor">
+            <a:schemeClr val="lt1"/>
+          </a:fontRef>
+        </p:style>
+        <p:txBody>
+          <a:bodyPr rtlCol="0" anchor="ctr"/>
+          <a:lstStyle/>
+          <a:p>
+            <a:pPr algn="ctr"/>
+          </a:p>
+        </p:txBody>
+      </p:sp>
+      <p:pic>
+        <p:nvPicPr>
           <p:cNvPr id="4" name="Picture 3" descr="phase_contingency.png"/>
           <p:cNvPicPr>
             <a:picLocks noChangeAspect="1"/>
@@ -4429,7 +5944,7 @@
 </p:sld>
 </file>
 
-<file path=ppt/slides/slide8.xml><?xml version="1.0" encoding="utf-8"?>
+<file path=ppt/slides/slide9.xml><?xml version="1.0" encoding="utf-8"?>
 <p:sld xmlns:a="http://schemas.openxmlformats.org/drawingml/2006/main" xmlns:p="http://schemas.openxmlformats.org/presentationml/2006/main" xmlns:r="http://schemas.openxmlformats.org/officeDocument/2006/relationships">
   <p:cSld>
     <p:spTree>
@@ -5249,253 +6764,6 @@
 </p:sld>
 </file>
 
-<file path=ppt/slides/slide9.xml><?xml version="1.0" encoding="utf-8"?>
-<p:sld xmlns:a="http://schemas.openxmlformats.org/drawingml/2006/main" xmlns:p="http://schemas.openxmlformats.org/presentationml/2006/main" xmlns:r="http://schemas.openxmlformats.org/officeDocument/2006/relationships">
-  <p:cSld>
-    <p:spTree>
-      <p:nvGrpSpPr>
-        <p:cNvPr id="1" name=""/>
-        <p:cNvGrpSpPr/>
-        <p:nvPr/>
-      </p:nvGrpSpPr>
-      <p:grpSpPr/>
-      <p:sp>
-        <p:nvSpPr>
-          <p:cNvPr id="2" name="TextBox 1"/>
-          <p:cNvSpPr txBox="1"/>
-          <p:nvPr/>
-        </p:nvSpPr>
-        <p:spPr>
-          <a:xfrm>
-            <a:off x="457200" y="201168"/>
-            <a:ext cx="11247120" cy="868680"/>
-          </a:xfrm>
-          <a:prstGeom prst="rect">
-            <a:avLst/>
-          </a:prstGeom>
-          <a:noFill/>
-        </p:spPr>
-        <p:txBody>
-          <a:bodyPr wrap="square">
-            <a:spAutoFit/>
-          </a:bodyPr>
-          <a:lstStyle/>
-          <a:p>
-            <a:r>
-              <a:rPr sz="2600" b="1">
-                <a:solidFill>
-                  <a:srgbClr val="1B4F72"/>
-                </a:solidFill>
-              </a:rPr>
-              <a:t>Summary — what is validated, and what is next</a:t>
-            </a:r>
-          </a:p>
-          <a:p>
-            <a:r>
-              <a:rPr sz="1400" i="1">
-                <a:solidFill>
-                  <a:srgbClr val="555555"/>
-                </a:solidFill>
-              </a:rPr>
-              <a:t>Every EarthCARE-validatable dimension of the Dec-2025 sample is complete</a:t>
-            </a:r>
-          </a:p>
-        </p:txBody>
-      </p:sp>
-      <p:sp>
-        <p:nvSpPr>
-          <p:cNvPr id="3" name="Rectangle 2"/>
-          <p:cNvSpPr/>
-          <p:nvPr/>
-        </p:nvSpPr>
-        <p:spPr>
-          <a:xfrm>
-            <a:off x="457200" y="1078992"/>
-            <a:ext cx="11247120" cy="31750"/>
-          </a:xfrm>
-          <a:prstGeom prst="rect">
-            <a:avLst/>
-          </a:prstGeom>
-          <a:solidFill>
-            <a:srgbClr val="2E6DA4"/>
-          </a:solidFill>
-          <a:ln>
-            <a:noFill/>
-          </a:ln>
-        </p:spPr>
-        <p:style>
-          <a:lnRef idx="1">
-            <a:schemeClr val="accent1"/>
-          </a:lnRef>
-          <a:fillRef idx="3">
-            <a:schemeClr val="accent1"/>
-          </a:fillRef>
-          <a:effectRef idx="2">
-            <a:schemeClr val="accent1"/>
-          </a:effectRef>
-          <a:fontRef idx="minor">
-            <a:schemeClr val="lt1"/>
-          </a:fontRef>
-        </p:style>
-        <p:txBody>
-          <a:bodyPr rtlCol="0" anchor="ctr"/>
-          <a:lstStyle/>
-          <a:p>
-            <a:pPr algn="ctr"/>
-          </a:p>
-        </p:txBody>
-      </p:sp>
-      <p:sp>
-        <p:nvSpPr>
-          <p:cNvPr id="4" name="TextBox 3"/>
-          <p:cNvSpPr txBox="1"/>
-          <p:nvPr/>
-        </p:nvSpPr>
-        <p:spPr>
-          <a:xfrm>
-            <a:off x="640080" y="1371600"/>
-            <a:ext cx="10972800" cy="5120640"/>
-          </a:xfrm>
-          <a:prstGeom prst="rect">
-            <a:avLst/>
-          </a:prstGeom>
-          <a:noFill/>
-        </p:spPr>
-        <p:txBody>
-          <a:bodyPr wrap="square">
-            <a:spAutoFit/>
-          </a:bodyPr>
-          <a:lstStyle/>
-          <a:p>
-            <a:pPr>
-              <a:spcAft>
-                <a:spcPts val="600"/>
-              </a:spcAft>
-            </a:pPr>
-            <a:r>
-              <a:rPr sz="1700" b="1">
-                <a:solidFill>
-                  <a:srgbClr val="1B4F72"/>
-                </a:solidFill>
-              </a:rPr>
-              <a:t>• VALIDATED (all median-primary, with confidence intervals):</a:t>
-            </a:r>
-          </a:p>
-          <a:p>
-            <a:pPr lvl="1">
-              <a:spcAft>
-                <a:spcPts val="600"/>
-              </a:spcAft>
-            </a:pPr>
-            <a:r>
-              <a:rPr sz="1500" b="0">
-                <a:solidFill>
-                  <a:srgbClr val="222222"/>
-                </a:solidFill>
-              </a:rPr>
-              <a:t>– CTH · water-COT · ice-COT · CER · CWP · cloud mask · phase — plus collocation methodology, surface-type &amp; phase stratification.</a:t>
-            </a:r>
-          </a:p>
-          <a:p>
-            <a:pPr>
-              <a:spcAft>
-                <a:spcPts val="600"/>
-              </a:spcAft>
-            </a:pPr>
-            <a:r>
-              <a:rPr sz="1700" b="1">
-                <a:solidFill>
-                  <a:srgbClr val="1B4F72"/>
-                </a:solidFill>
-              </a:rPr>
-              <a:t>• THE UNIFYING STORY — two independent limitations of the polar-daytime solar retrieval:</a:t>
-            </a:r>
-          </a:p>
-          <a:p>
-            <a:pPr lvl="1">
-              <a:spcAft>
-                <a:spcPts val="600"/>
-              </a:spcAft>
-            </a:pPr>
-            <a:r>
-              <a:rPr sz="1500" b="0">
-                <a:solidFill>
-                  <a:srgbClr val="222222"/>
-                </a:solidFill>
-              </a:rPr>
-              <a:t>– (1) bright-surface optical-depth SATURATION (surface-driven; propagates into CWP; spares open water),</a:t>
-            </a:r>
-          </a:p>
-          <a:p>
-            <a:pPr lvl="1">
-              <a:spcAft>
-                <a:spcPts val="600"/>
-              </a:spcAft>
-            </a:pPr>
-            <a:r>
-              <a:rPr sz="1500" b="0">
-                <a:solidFill>
-                  <a:srgbClr val="222222"/>
-                </a:solidFill>
-              </a:rPr>
-              <a:t>– (2) an intrinsic LIQUID PHASE BIAS (POD_ice 62%; surface-independent).</a:t>
-            </a:r>
-          </a:p>
-          <a:p>
-            <a:pPr lvl="1">
-              <a:spcAft>
-                <a:spcPts val="600"/>
-              </a:spcAft>
-            </a:pPr>
-            <a:r>
-              <a:rPr sz="1500" b="0">
-                <a:solidFill>
-                  <a:srgbClr val="222222"/>
-                </a:solidFill>
-              </a:rPr>
-              <a:t>– Thermal CTH is strong (−0.25 km); CER is robust. These are the trustworthy products over the cryosphere.</a:t>
-            </a:r>
-          </a:p>
-          <a:p>
-            <a:pPr>
-              <a:spcAft>
-                <a:spcPts val="600"/>
-              </a:spcAft>
-            </a:pPr>
-            <a:r>
-              <a:rPr sz="1700" b="1">
-                <a:solidFill>
-                  <a:srgbClr val="1B4F72"/>
-                </a:solidFill>
-              </a:rPr>
-              <a:t>• NEXT STEPS (require new processing, not further analysis):</a:t>
-            </a:r>
-          </a:p>
-          <a:p>
-            <a:pPr lvl="1">
-              <a:spcAft>
-                <a:spcPts val="600"/>
-              </a:spcAft>
-            </a:pPr>
-            <a:r>
-              <a:rPr sz="1500" b="0">
-                <a:solidFill>
-                  <a:srgbClr val="222222"/>
-                </a:solidFill>
-              </a:rPr>
-              <a:t>– Arctic / boreal-summer month (Arctic sea-ice &amp; Greenland) · Sentinel-3B · other seasons.</a:t>
-            </a:r>
-          </a:p>
-        </p:txBody>
-      </p:sp>
-    </p:spTree>
-  </p:cSld>
-  <p:clrMapOvr>
-    <a:masterClrMapping/>
-  </p:clrMapOvr>
-</p:sld>
-</file>
-
 <file path=ppt/theme/theme1.xml><?xml version="1.0" encoding="utf-8"?>
 <a:theme xmlns:a="http://schemas.openxmlformats.org/drawingml/2006/main" name="Office Theme">
   <a:themeElements>
@@ -5814,4 +7082,324 @@
   </a:objectDefaults>
   <a:extraClrSchemeLst/>
 </a:theme>
+</file>
+
+<file path=ppt/theme/theme2.xml><?xml version="1.0" encoding="utf-8"?>
+<a:theme xmlns:a="http://schemas.openxmlformats.org/drawingml/2006/main" name="Office Theme">
+  <a:themeElements>
+    <a:clrScheme name="Office">
+      <a:dk1>
+        <a:sysClr val="windowText" lastClr="000000"/>
+      </a:dk1>
+      <a:lt1>
+        <a:sysClr val="window" lastClr="FFFFFF"/>
+      </a:lt1>
+      <a:dk2>
+        <a:srgbClr val="1F497D"/>
+      </a:dk2>
+      <a:lt2>
+        <a:srgbClr val="EEECE1"/>
+      </a:lt2>
+      <a:accent1>
+        <a:srgbClr val="4F81BD"/>
+      </a:accent1>
+      <a:accent2>
+        <a:srgbClr val="C0504D"/>
+      </a:accent2>
+      <a:accent3>
+        <a:srgbClr val="9BBB59"/>
+      </a:accent3>
+      <a:accent4>
+        <a:srgbClr val="8064A2"/>
+      </a:accent4>
+      <a:accent5>
+        <a:srgbClr val="4BACC6"/>
+      </a:accent5>
+      <a:accent6>
+        <a:srgbClr val="F79646"/>
+      </a:accent6>
+      <a:hlink>
+        <a:srgbClr val="0000FF"/>
+      </a:hlink>
+      <a:folHlink>
+        <a:srgbClr val="800080"/>
+      </a:folHlink>
+    </a:clrScheme>
+    <a:fontScheme name="Office">
+      <a:majorFont>
+        <a:latin typeface="Calibri"/>
+        <a:ea typeface=""/>
+        <a:cs typeface=""/>
+        <a:font script="Jpan" typeface="ＭＳ Ｐゴシック"/>
+        <a:font script="Hang" typeface="맑은 고딕"/>
+        <a:font script="Hans" typeface="宋体"/>
+        <a:font script="Hant" typeface="新細明體"/>
+        <a:font script="Arab" typeface="Times New Roman"/>
+        <a:font script="Hebr" typeface="Times New Roman"/>
+        <a:font script="Thai" typeface="Angsana New"/>
+        <a:font script="Ethi" typeface="Nyala"/>
+        <a:font script="Beng" typeface="Vrinda"/>
+        <a:font script="Gujr" typeface="Shruti"/>
+        <a:font script="Khmr" typeface="MoolBoran"/>
+        <a:font script="Knda" typeface="Tunga"/>
+        <a:font script="Guru" typeface="Raavi"/>
+        <a:font script="Cans" typeface="Euphemia"/>
+        <a:font script="Cher" typeface="Plantagenet Cherokee"/>
+        <a:font script="Yiii" typeface="Microsoft Yi Baiti"/>
+        <a:font script="Tibt" typeface="Microsoft Himalaya"/>
+        <a:font script="Thaa" typeface="MV Boli"/>
+        <a:font script="Deva" typeface="Mangal"/>
+        <a:font script="Telu" typeface="Gautami"/>
+        <a:font script="Taml" typeface="Latha"/>
+        <a:font script="Syrc" typeface="Estrangelo Edessa"/>
+        <a:font script="Orya" typeface="Kalinga"/>
+        <a:font script="Mlym" typeface="Kartika"/>
+        <a:font script="Laoo" typeface="DokChampa"/>
+        <a:font script="Sinh" typeface="Iskoola Pota"/>
+        <a:font script="Mong" typeface="Mongolian Baiti"/>
+        <a:font script="Viet" typeface="Times New Roman"/>
+        <a:font script="Uigh" typeface="Microsoft Uighur"/>
+        <a:font script="Geor" typeface="Sylfaen"/>
+      </a:majorFont>
+      <a:minorFont>
+        <a:latin typeface="Calibri"/>
+        <a:ea typeface=""/>
+        <a:cs typeface=""/>
+        <a:font script="Jpan" typeface="ＭＳ Ｐゴシック"/>
+        <a:font script="Hang" typeface="맑은 고딕"/>
+        <a:font script="Hans" typeface="宋体"/>
+        <a:font script="Hant" typeface="新細明體"/>
+        <a:font script="Arab" typeface="Arial"/>
+        <a:font script="Hebr" typeface="Arial"/>
+        <a:font script="Thai" typeface="Cordia New"/>
+        <a:font script="Ethi" typeface="Nyala"/>
+        <a:font script="Beng" typeface="Vrinda"/>
+        <a:font script="Gujr" typeface="Shruti"/>
+        <a:font script="Khmr" typeface="DaunPenh"/>
+        <a:font script="Knda" typeface="Tunga"/>
+        <a:font script="Guru" typeface="Raavi"/>
+        <a:font script="Cans" typeface="Euphemia"/>
+        <a:font script="Cher" typeface="Plantagenet Cherokee"/>
+        <a:font script="Yiii" typeface="Microsoft Yi Baiti"/>
+        <a:font script="Tibt" typeface="Microsoft Himalaya"/>
+        <a:font script="Thaa" typeface="MV Boli"/>
+        <a:font script="Deva" typeface="Mangal"/>
+        <a:font script="Telu" typeface="Gautami"/>
+        <a:font script="Taml" typeface="Latha"/>
+        <a:font script="Syrc" typeface="Estrangelo Edessa"/>
+        <a:font script="Orya" typeface="Kalinga"/>
+        <a:font script="Mlym" typeface="Kartika"/>
+        <a:font script="Laoo" typeface="DokChampa"/>
+        <a:font script="Sinh" typeface="Iskoola Pota"/>
+        <a:font script="Mong" typeface="Mongolian Baiti"/>
+        <a:font script="Viet" typeface="Arial"/>
+        <a:font script="Uigh" typeface="Microsoft Uighur"/>
+        <a:font script="Geor" typeface="Sylfaen"/>
+      </a:minorFont>
+    </a:fontScheme>
+    <a:fmtScheme name="Office">
+      <a:fillStyleLst>
+        <a:solidFill>
+          <a:schemeClr val="phClr"/>
+        </a:solidFill>
+        <a:gradFill rotWithShape="1">
+          <a:gsLst>
+            <a:gs pos="0">
+              <a:schemeClr val="phClr">
+                <a:tint val="50000"/>
+                <a:satMod val="300000"/>
+              </a:schemeClr>
+            </a:gs>
+            <a:gs pos="35000">
+              <a:schemeClr val="phClr">
+                <a:tint val="37000"/>
+                <a:satMod val="300000"/>
+              </a:schemeClr>
+            </a:gs>
+            <a:gs pos="100000">
+              <a:schemeClr val="phClr">
+                <a:tint val="15000"/>
+                <a:satMod val="350000"/>
+              </a:schemeClr>
+            </a:gs>
+          </a:gsLst>
+          <a:lin ang="16200000" scaled="1"/>
+        </a:gradFill>
+        <a:gradFill rotWithShape="1">
+          <a:gsLst>
+            <a:gs pos="0">
+              <a:schemeClr val="phClr">
+                <a:tint val="100000"/>
+                <a:shade val="100000"/>
+                <a:satMod val="130000"/>
+              </a:schemeClr>
+            </a:gs>
+            <a:gs pos="100000">
+              <a:schemeClr val="phClr">
+                <a:tint val="50000"/>
+                <a:shade val="100000"/>
+                <a:satMod val="350000"/>
+              </a:schemeClr>
+            </a:gs>
+          </a:gsLst>
+          <a:lin ang="16200000" scaled="0"/>
+        </a:gradFill>
+      </a:fillStyleLst>
+      <a:lnStyleLst>
+        <a:ln w="9525" cap="flat" cmpd="sng" algn="ctr">
+          <a:solidFill>
+            <a:schemeClr val="phClr">
+              <a:shade val="95000"/>
+              <a:satMod val="105000"/>
+            </a:schemeClr>
+          </a:solidFill>
+          <a:prstDash val="solid"/>
+        </a:ln>
+        <a:ln w="25400" cap="flat" cmpd="sng" algn="ctr">
+          <a:solidFill>
+            <a:schemeClr val="phClr"/>
+          </a:solidFill>
+          <a:prstDash val="solid"/>
+        </a:ln>
+        <a:ln w="38100" cap="flat" cmpd="sng" algn="ctr">
+          <a:solidFill>
+            <a:schemeClr val="phClr"/>
+          </a:solidFill>
+          <a:prstDash val="solid"/>
+        </a:ln>
+      </a:lnStyleLst>
+      <a:effectStyleLst>
+        <a:effectStyle>
+          <a:effectLst>
+            <a:outerShdw blurRad="40000" dist="20000" dir="5400000" rotWithShape="0">
+              <a:srgbClr val="000000">
+                <a:alpha val="38000"/>
+              </a:srgbClr>
+            </a:outerShdw>
+          </a:effectLst>
+        </a:effectStyle>
+        <a:effectStyle>
+          <a:effectLst>
+            <a:outerShdw blurRad="40000" dist="23000" dir="5400000" rotWithShape="0">
+              <a:srgbClr val="000000">
+                <a:alpha val="35000"/>
+              </a:srgbClr>
+            </a:outerShdw>
+          </a:effectLst>
+        </a:effectStyle>
+        <a:effectStyle>
+          <a:effectLst>
+            <a:outerShdw blurRad="40000" dist="23000" dir="5400000" rotWithShape="0">
+              <a:srgbClr val="000000">
+                <a:alpha val="35000"/>
+              </a:srgbClr>
+            </a:outerShdw>
+          </a:effectLst>
+          <a:scene3d>
+            <a:camera prst="orthographicFront">
+              <a:rot lat="0" lon="0" rev="0"/>
+            </a:camera>
+            <a:lightRig rig="threePt" dir="t">
+              <a:rot lat="0" lon="0" rev="1200000"/>
+            </a:lightRig>
+          </a:scene3d>
+          <a:sp3d>
+            <a:bevelT w="63500" h="25400"/>
+          </a:sp3d>
+        </a:effectStyle>
+      </a:effectStyleLst>
+      <a:bgFillStyleLst>
+        <a:solidFill>
+          <a:schemeClr val="phClr"/>
+        </a:solidFill>
+        <a:gradFill rotWithShape="1">
+          <a:gsLst>
+            <a:gs pos="0">
+              <a:schemeClr val="phClr">
+                <a:tint val="40000"/>
+                <a:satMod val="350000"/>
+              </a:schemeClr>
+            </a:gs>
+            <a:gs pos="40000">
+              <a:schemeClr val="phClr">
+                <a:tint val="45000"/>
+                <a:shade val="99000"/>
+                <a:satMod val="350000"/>
+              </a:schemeClr>
+            </a:gs>
+            <a:gs pos="100000">
+              <a:schemeClr val="phClr">
+                <a:shade val="20000"/>
+                <a:satMod val="255000"/>
+              </a:schemeClr>
+            </a:gs>
+          </a:gsLst>
+          <a:path path="circle">
+            <a:fillToRect l="50000" t="-80000" r="50000" b="180000"/>
+          </a:path>
+        </a:gradFill>
+        <a:gradFill rotWithShape="1">
+          <a:gsLst>
+            <a:gs pos="0">
+              <a:schemeClr val="phClr">
+                <a:tint val="80000"/>
+                <a:satMod val="300000"/>
+              </a:schemeClr>
+            </a:gs>
+            <a:gs pos="100000">
+              <a:schemeClr val="phClr">
+                <a:shade val="30000"/>
+                <a:satMod val="200000"/>
+              </a:schemeClr>
+            </a:gs>
+          </a:gsLst>
+          <a:path path="circle">
+            <a:fillToRect l="50000" t="50000" r="50000" b="50000"/>
+          </a:path>
+        </a:gradFill>
+      </a:bgFillStyleLst>
+    </a:fmtScheme>
+  </a:themeElements>
+  <a:objectDefaults>
+    <a:spDef>
+      <a:spPr/>
+      <a:bodyPr/>
+      <a:lstStyle/>
+      <a:style>
+        <a:lnRef idx="1">
+          <a:schemeClr val="accent1"/>
+        </a:lnRef>
+        <a:fillRef idx="3">
+          <a:schemeClr val="accent1"/>
+        </a:fillRef>
+        <a:effectRef idx="2">
+          <a:schemeClr val="accent1"/>
+        </a:effectRef>
+        <a:fontRef idx="minor">
+          <a:schemeClr val="lt1"/>
+        </a:fontRef>
+      </a:style>
+    </a:spDef>
+    <a:lnDef>
+      <a:spPr/>
+      <a:bodyPr/>
+      <a:lstStyle/>
+      <a:style>
+        <a:lnRef idx="2">
+          <a:schemeClr val="accent1"/>
+        </a:lnRef>
+        <a:fillRef idx="0">
+          <a:schemeClr val="accent1"/>
+        </a:fillRef>
+        <a:effectRef idx="1">
+          <a:schemeClr val="accent1"/>
+        </a:effectRef>
+        <a:fontRef idx="minor">
+          <a:schemeClr val="tx1"/>
+        </a:fontRef>
+      </a:style>
+    </a:lnDef>
+  </a:objectDefaults>
+  <a:extraClrSchemeLst/>
+</a:theme>
 </file>
</xml_diff>